<commit_message>
Actualizar PPT de Retail, Tradicional e Innovación
Sincroniza los .pptx regenerados con los últimos cambios de datos/deck para dejar el repo al día antes del deploy.

Co-Authored-By: Claude Sonnet 5 <noreply@anthropic.com>
</commit_message>
<xml_diff>
--- a/retail/INFORME_RETAIL.pptx
+++ b/retail/INFORME_RETAIL.pptx
@@ -4,16 +4,16 @@
   <p:sldMasterIdLst>
     <p:sldMasterId id="2147483648" r:id="rId1"/>
   </p:sldMasterIdLst>
+  <p:notesMasterIdLst>
+    <p:notesMasterId r:id="rId5"/>
+  </p:notesMasterIdLst>
   <p:sldIdLst>
     <p:sldId id="256" r:id="rId2"/>
     <p:sldId id="257" r:id="rId3"/>
     <p:sldId id="258" r:id="rId4"/>
   </p:sldIdLst>
-  <p:notesMasterIdLst>
-    <p:notesMasterId r:id="rId5"/>
-  </p:notesMasterIdLst>
-  <p:sldSz cx="12191695" cy="6858000"/>
-  <p:notesSz cx="6858000" cy="12191695"/>
+  <p:sldSz cx="12192000" cy="6858000"/>
+  <p:notesSz cx="6858000" cy="12192000"/>
   <p:defaultTextStyle>
     <a:lvl1pPr marL="0" algn="l" defTabSz="914400" rtl="0" eaLnBrk="1" latinLnBrk="0" hangingPunct="1">
       <a:defRPr sz="1800" kern="1200">
@@ -106,6 +106,11 @@
       </a:defRPr>
     </a:lvl9pPr>
   </p:defaultTextStyle>
+  <p:extLst>
+    <p:ext uri="{EFAFB233-063F-42B5-8137-9DF3F51BA10A}">
+      <p15:sldGuideLst xmlns:p15="http://schemas.microsoft.com/office/powerpoint/2012/main"/>
+    </p:ext>
+  </p:extLst>
 </p:presentation>
 </file>
 
@@ -131,234 +136,10 @@
           <a:chExt cx="0" cy="0"/>
         </a:xfrm>
       </p:grpSpPr>
-      <p:sp>
-        <p:nvSpPr>
-          <p:cNvPr id="2" name="Header Placeholder 1"/>
-          <p:cNvSpPr>
-            <a:spLocks noGrp="1"/>
-          </p:cNvSpPr>
-          <p:nvPr>
-            <p:ph type="hdr" sz="quarter"/>
-          </p:nvPr>
-        </p:nvSpPr>
-        <p:spPr>
-          <a:xfrm>
-            <a:off x="0" y="0"/>
-            <a:ext cx="2971800" cy="458788"/>
-          </a:xfrm>
-          <a:prstGeom prst="rect">
-            <a:avLst/>
-          </a:prstGeom>
-        </p:spPr>
-        <p:txBody>
-          <a:bodyPr vert="horz" lIns="91440" tIns="45720" rIns="91440" bIns="45720" rtlCol="0"/>
-          <a:lstStyle>
-            <a:lvl1pPr algn="l">
-              <a:defRPr sz="1200"/>
-            </a:lvl1pPr>
-          </a:lstStyle>
-          <a:p>
-            <a:endParaRPr lang="en-US"/>
-          </a:p>
-        </p:txBody>
-      </p:sp>
-      <p:sp>
-        <p:nvSpPr>
-          <p:cNvPr id="3" name="Date Placeholder 2"/>
-          <p:cNvSpPr>
-            <a:spLocks noGrp="1"/>
-          </p:cNvSpPr>
-          <p:nvPr>
-            <p:ph type="dt" idx="1"/>
-          </p:nvPr>
-        </p:nvSpPr>
-        <p:spPr>
-          <a:xfrm>
-            <a:off x="3884613" y="0"/>
-            <a:ext cx="2971800" cy="458788"/>
-          </a:xfrm>
-          <a:prstGeom prst="rect">
-            <a:avLst/>
-          </a:prstGeom>
-        </p:spPr>
-        <p:txBody>
-          <a:bodyPr vert="horz" lIns="91440" tIns="45720" rIns="91440" bIns="45720" rtlCol="0"/>
-          <a:lstStyle>
-            <a:lvl1pPr algn="r">
-              <a:defRPr sz="1200"/>
-            </a:lvl1pPr>
-          </a:lstStyle>
-          <a:p>
-            <a:fld id="{5282F153-3F37-0F45-9E97-73ACFA13230C}" type="datetimeFigureOut">
-              <a:rPr lang="en-US"/>
-              <a:t>7/23/19</a:t>
-            </a:fld>
-            <a:endParaRPr lang="en-US"/>
-          </a:p>
-        </p:txBody>
-      </p:sp>
-      <p:sp>
-        <p:nvSpPr>
-          <p:cNvPr id="4" name="Slide Image Placeholder 3"/>
-          <p:cNvSpPr>
-            <a:spLocks noGrp="1" noRot="1" noChangeAspect="1"/>
-          </p:cNvSpPr>
-          <p:nvPr>
-            <p:ph type="sldImg" idx="2"/>
-          </p:nvPr>
-        </p:nvSpPr>
-        <p:spPr>
-          <a:xfrm>
-            <a:off x="685800" y="1143000"/>
-            <a:ext cx="5486400" cy="3086100"/>
-          </a:xfrm>
-          <a:prstGeom prst="rect">
-            <a:avLst/>
-          </a:prstGeom>
-          <a:noFill/>
-          <a:ln w="12700">
-            <a:solidFill>
-              <a:prstClr val="black"/>
-            </a:solidFill>
-          </a:ln>
-        </p:spPr>
-        <p:txBody>
-          <a:bodyPr vert="horz" lIns="91440" tIns="45720" rIns="91440" bIns="45720" rtlCol="0" anchor="ctr"/>
-          <a:lstStyle/>
-          <a:p>
-            <a:endParaRPr lang="en-US"/>
-          </a:p>
-        </p:txBody>
-      </p:sp>
-      <p:sp>
-        <p:nvSpPr>
-          <p:cNvPr id="5" name="Notes Placeholder 4"/>
-          <p:cNvSpPr>
-            <a:spLocks noGrp="1"/>
-          </p:cNvSpPr>
-          <p:nvPr>
-            <p:ph type="body" sz="quarter" idx="3"/>
-          </p:nvPr>
-        </p:nvSpPr>
-        <p:spPr>
-          <a:xfrm>
-            <a:off x="685800" y="4400550"/>
-            <a:ext cx="5486400" cy="3600450"/>
-          </a:xfrm>
-          <a:prstGeom prst="rect">
-            <a:avLst/>
-          </a:prstGeom>
-        </p:spPr>
-        <p:txBody>
-          <a:bodyPr vert="horz" lIns="91440" tIns="45720" rIns="91440" bIns="45720" rtlCol="0"/>
-          <a:lstStyle/>
-          <a:p>
-            <a:pPr lvl="0"/>
-            <a:r>
-              <a:rPr lang="en-US"/>
-              <a:t>Click to edit Master text styles</a:t>
-            </a:r>
-          </a:p>
-          <a:p>
-            <a:pPr lvl="1"/>
-            <a:r>
-              <a:rPr lang="en-US"/>
-              <a:t>Second level</a:t>
-            </a:r>
-          </a:p>
-          <a:p>
-            <a:pPr lvl="2"/>
-            <a:r>
-              <a:rPr lang="en-US"/>
-              <a:t>Third level</a:t>
-            </a:r>
-          </a:p>
-          <a:p>
-            <a:pPr lvl="3"/>
-            <a:r>
-              <a:rPr lang="en-US"/>
-              <a:t>Fourth level</a:t>
-            </a:r>
-          </a:p>
-          <a:p>
-            <a:pPr lvl="4"/>
-            <a:r>
-              <a:rPr lang="en-US"/>
-              <a:t>Fifth level</a:t>
-            </a:r>
-          </a:p>
-        </p:txBody>
-      </p:sp>
-      <p:sp>
-        <p:nvSpPr>
-          <p:cNvPr id="6" name="Footer Placeholder 5"/>
-          <p:cNvSpPr>
-            <a:spLocks noGrp="1"/>
-          </p:cNvSpPr>
-          <p:nvPr>
-            <p:ph type="ftr" sz="quarter" idx="4"/>
-          </p:nvPr>
-        </p:nvSpPr>
-        <p:spPr>
-          <a:xfrm>
-            <a:off x="0" y="8685213"/>
-            <a:ext cx="2971800" cy="458787"/>
-          </a:xfrm>
-          <a:prstGeom prst="rect">
-            <a:avLst/>
-          </a:prstGeom>
-        </p:spPr>
-        <p:txBody>
-          <a:bodyPr vert="horz" lIns="91440" tIns="45720" rIns="91440" bIns="45720" rtlCol="0" anchor="b"/>
-          <a:lstStyle>
-            <a:lvl1pPr algn="l">
-              <a:defRPr sz="1200"/>
-            </a:lvl1pPr>
-          </a:lstStyle>
-          <a:p>
-            <a:endParaRPr lang="en-US"/>
-          </a:p>
-        </p:txBody>
-      </p:sp>
-      <p:sp>
-        <p:nvSpPr>
-          <p:cNvPr id="7" name="Slide Number Placeholder 6"/>
-          <p:cNvSpPr>
-            <a:spLocks noGrp="1"/>
-          </p:cNvSpPr>
-          <p:nvPr>
-            <p:ph type="sldNum" sz="quarter" idx="5"/>
-          </p:nvPr>
-        </p:nvSpPr>
-        <p:spPr>
-          <a:xfrm>
-            <a:off x="3884613" y="8685213"/>
-            <a:ext cx="2971800" cy="458787"/>
-          </a:xfrm>
-          <a:prstGeom prst="rect">
-            <a:avLst/>
-          </a:prstGeom>
-        </p:spPr>
-        <p:txBody>
-          <a:bodyPr vert="horz" lIns="91440" tIns="45720" rIns="91440" bIns="45720" rtlCol="0" anchor="b"/>
-          <a:lstStyle>
-            <a:lvl1pPr algn="r">
-              <a:defRPr sz="1200"/>
-            </a:lvl1pPr>
-          </a:lstStyle>
-          <a:p>
-            <a:fld id="{CE5E9CC1-C706-0F49-92D6-E571CC5EEA8F}" type="slidenum">
-              <a:rPr lang="en-US"/>
-              <a:t>‹#›</a:t>
-            </a:fld>
-            <a:endParaRPr lang="en-US"/>
-          </a:p>
-        </p:txBody>
-      </p:sp>
     </p:spTree>
     <p:extLst>
       <p:ext uri="{BB962C8B-B14F-4D97-AF65-F5344CB8AC3E}">
-        <p14:creationId xmlns:p14="http://schemas.microsoft.com/office/powerpoint/2010/main" val="1024086991"/>
+        <p14:creationId xmlns:p14="http://schemas.microsoft.com/office/powerpoint/2010/main" val="2787837079"/>
       </p:ext>
     </p:extLst>
   </p:cSld>
@@ -502,10 +283,6 @@
           <a:bodyPr/>
           <a:lstStyle/>
           <a:p>
-            <a:r>
-              <a:rPr lang="en-US" dirty="0"/>
-              <a:t/>
-            </a:r>
             <a:endParaRPr lang="en-US" dirty="0"/>
           </a:p>
         </p:txBody>
@@ -590,10 +367,6 @@
           <a:bodyPr/>
           <a:lstStyle/>
           <a:p>
-            <a:r>
-              <a:rPr lang="en-US" dirty="0"/>
-              <a:t/>
-            </a:r>
             <a:endParaRPr lang="en-US" dirty="0"/>
           </a:p>
         </p:txBody>
@@ -678,10 +451,6 @@
           <a:bodyPr/>
           <a:lstStyle/>
           <a:p>
-            <a:r>
-              <a:rPr lang="en-US" dirty="0"/>
-              <a:t/>
-            </a:r>
             <a:endParaRPr lang="en-US" dirty="0"/>
           </a:p>
         </p:txBody>
@@ -755,6 +524,11 @@
 <file path=ppt/slideMasters/slideMaster1.xml><?xml version="1.0" encoding="utf-8"?>
 <p:sldMaster xmlns:a="http://schemas.openxmlformats.org/drawingml/2006/main" xmlns:r="http://schemas.openxmlformats.org/officeDocument/2006/relationships" xmlns:p="http://schemas.openxmlformats.org/presentationml/2006/main">
   <p:cSld>
+    <p:bg>
+      <p:bgRef idx="1001">
+        <a:schemeClr val="bg1"/>
+      </p:bgRef>
+    </p:bg>
     <p:spTree>
       <p:nvGrpSpPr>
         <p:cNvPr id="1" name=""/>
@@ -1048,14 +822,14 @@
       </p:grpSpPr>
       <p:pic>
         <p:nvPicPr>
-          <p:cNvPr id="2" name="Image 0" descr="C:\01_Repositorios\02_CRM\02_Informe_Semetral\dash\retail\ppt_slides\sk_00_main.png">    </p:cNvPr>
+          <p:cNvPr id="2" name="Image 0" descr="C:\01_Repositorios\02_CRM\02_Informe_Semetral\dash\retail\ppt_slides\sk_00_main.png"/>
           <p:cNvPicPr>
             <a:picLocks noChangeAspect="1"/>
           </p:cNvPicPr>
           <p:nvPr/>
         </p:nvPicPr>
         <p:blipFill>
-          <a:blip r:embed="rId1"/>
+          <a:blip r:embed="rId3"/>
           <a:stretch>
             <a:fillRect/>
           </a:stretch>
@@ -1091,7 +865,7 @@
           <a:bodyPr wrap="square" lIns="0" tIns="0" rIns="0" bIns="0" rtlCol="0" anchor="t"/>
           <a:lstStyle/>
           <a:p>
-            <a:pPr algn="l" indent="0" marL="0">
+            <a:pPr marL="0" indent="0" algn="l">
               <a:buNone/>
             </a:pPr>
             <a:r>
@@ -1130,7 +904,7 @@
           <a:bodyPr wrap="square" lIns="0" tIns="0" rIns="0" bIns="0" rtlCol="0" anchor="t"/>
           <a:lstStyle/>
           <a:p>
-            <a:pPr algn="l" indent="0" marL="0">
+            <a:pPr marL="0" indent="0" algn="l">
               <a:buNone/>
             </a:pPr>
             <a:r>
@@ -1169,7 +943,7 @@
           <a:bodyPr wrap="square" lIns="0" tIns="0" rIns="0" bIns="0" rtlCol="0" anchor="t"/>
           <a:lstStyle/>
           <a:p>
-            <a:pPr algn="l" indent="0" marL="0">
+            <a:pPr marL="0" indent="0" algn="l">
               <a:buNone/>
             </a:pPr>
             <a:r>
@@ -1208,7 +982,7 @@
           <a:bodyPr wrap="square" lIns="0" tIns="0" rIns="0" bIns="0" rtlCol="0" anchor="t"/>
           <a:lstStyle/>
           <a:p>
-            <a:pPr algn="l" indent="0" marL="0">
+            <a:pPr marL="0" indent="0" algn="l">
               <a:buNone/>
             </a:pPr>
             <a:r>
@@ -1247,7 +1021,7 @@
           <a:bodyPr wrap="square" lIns="0" tIns="0" rIns="0" bIns="0" rtlCol="0" anchor="t"/>
           <a:lstStyle/>
           <a:p>
-            <a:pPr algn="l" indent="0" marL="0">
+            <a:pPr marL="0" indent="0" algn="l">
               <a:buNone/>
             </a:pPr>
             <a:r>
@@ -1286,7 +1060,7 @@
           <a:bodyPr wrap="square" lIns="0" tIns="0" rIns="0" bIns="0" rtlCol="0" anchor="t"/>
           <a:lstStyle/>
           <a:p>
-            <a:pPr algn="l" indent="0" marL="0">
+            <a:pPr marL="0" indent="0" algn="l">
               <a:buNone/>
             </a:pPr>
             <a:r>
@@ -1325,7 +1099,7 @@
           <a:bodyPr wrap="square" lIns="0" tIns="0" rIns="0" bIns="0" rtlCol="0" anchor="t"/>
           <a:lstStyle/>
           <a:p>
-            <a:pPr algn="l" indent="0" marL="0">
+            <a:pPr marL="0" indent="0" algn="l">
               <a:buNone/>
             </a:pPr>
             <a:r>
@@ -1364,7 +1138,7 @@
           <a:bodyPr wrap="square" lIns="0" tIns="0" rIns="0" bIns="0" rtlCol="0" anchor="t"/>
           <a:lstStyle/>
           <a:p>
-            <a:pPr algn="l" indent="0" marL="0">
+            <a:pPr marL="0" indent="0" algn="l">
               <a:buNone/>
             </a:pPr>
             <a:r>
@@ -1403,7 +1177,7 @@
           <a:bodyPr wrap="square" lIns="0" tIns="0" rIns="0" bIns="0" rtlCol="0" anchor="t"/>
           <a:lstStyle/>
           <a:p>
-            <a:pPr algn="l" indent="0" marL="0">
+            <a:pPr marL="0" indent="0" algn="l">
               <a:buNone/>
             </a:pPr>
             <a:r>
@@ -1442,7 +1216,7 @@
           <a:bodyPr wrap="square" lIns="0" tIns="0" rIns="0" bIns="0" rtlCol="0" anchor="t"/>
           <a:lstStyle/>
           <a:p>
-            <a:pPr algn="l" indent="0" marL="0">
+            <a:pPr marL="0" indent="0" algn="l">
               <a:buNone/>
             </a:pPr>
             <a:r>
@@ -1468,7 +1242,7 @@
         </p:nvSpPr>
         <p:spPr>
           <a:xfrm>
-            <a:off x="1573879" y="2364135"/>
+            <a:off x="1608383" y="2329631"/>
             <a:ext cx="1203780" cy="133350"/>
           </a:xfrm>
           <a:prstGeom prst="rect">
@@ -1481,7 +1255,7 @@
           <a:bodyPr wrap="square" lIns="0" tIns="114300" rIns="114300" bIns="0" rtlCol="0" anchor="ctr"/>
           <a:lstStyle/>
           <a:p>
-            <a:pPr algn="r" indent="0" marL="0">
+            <a:pPr marL="0" indent="0" algn="r">
               <a:buNone/>
             </a:pPr>
             <a:r>
@@ -1507,7 +1281,7 @@
         </p:nvSpPr>
         <p:spPr>
           <a:xfrm>
-            <a:off x="3712632" y="2364135"/>
+            <a:off x="3747136" y="2329631"/>
             <a:ext cx="1071031" cy="133350"/>
           </a:xfrm>
           <a:prstGeom prst="rect">
@@ -1520,7 +1294,7 @@
           <a:bodyPr wrap="square" lIns="0" tIns="114300" rIns="114300" bIns="0" rtlCol="0" anchor="ctr"/>
           <a:lstStyle/>
           <a:p>
-            <a:pPr algn="r" indent="0" marL="0">
+            <a:pPr marL="0" indent="0" algn="r">
               <a:buNone/>
             </a:pPr>
             <a:r>
@@ -1546,7 +1320,7 @@
         </p:nvSpPr>
         <p:spPr>
           <a:xfrm>
-            <a:off x="4750869" y="2364135"/>
+            <a:off x="4785373" y="2329631"/>
             <a:ext cx="1125909" cy="133350"/>
           </a:xfrm>
           <a:prstGeom prst="rect">
@@ -1559,7 +1333,7 @@
           <a:bodyPr wrap="square" lIns="0" tIns="114300" rIns="114300" bIns="0" rtlCol="0" anchor="ctr"/>
           <a:lstStyle/>
           <a:p>
-            <a:pPr algn="r" indent="0" marL="0">
+            <a:pPr marL="0" indent="0" algn="r">
               <a:buNone/>
             </a:pPr>
             <a:r>
@@ -1598,7 +1372,7 @@
           <a:bodyPr wrap="square" lIns="0" tIns="114300" rIns="114300" bIns="0" rtlCol="0" anchor="ctr"/>
           <a:lstStyle/>
           <a:p>
-            <a:pPr algn="l" indent="0" marL="0">
+            <a:pPr marL="0" indent="0" algn="l">
               <a:buNone/>
             </a:pPr>
             <a:r>
@@ -1624,7 +1398,7 @@
         </p:nvSpPr>
         <p:spPr>
           <a:xfrm>
-            <a:off x="2748674" y="2364135"/>
+            <a:off x="2783178" y="2329631"/>
             <a:ext cx="995153" cy="133350"/>
           </a:xfrm>
           <a:prstGeom prst="rect">
@@ -1637,7 +1411,7 @@
           <a:bodyPr wrap="square" lIns="0" tIns="114300" rIns="114300" bIns="0" rtlCol="0" anchor="ctr"/>
           <a:lstStyle/>
           <a:p>
-            <a:pPr algn="r" indent="0" marL="0">
+            <a:pPr marL="0" indent="0" algn="r">
               <a:buNone/>
             </a:pPr>
             <a:r>
@@ -1676,7 +1450,7 @@
           <a:bodyPr wrap="square" lIns="0" tIns="0" rIns="0" bIns="0" rtlCol="0" anchor="t"/>
           <a:lstStyle/>
           <a:p>
-            <a:pPr algn="l" indent="0" marL="0">
+            <a:pPr marL="0" indent="0" algn="l">
               <a:buNone/>
             </a:pPr>
             <a:r>
@@ -1715,7 +1489,7 @@
           <a:bodyPr wrap="square" lIns="0" tIns="114300" rIns="114300" bIns="0" rtlCol="0" anchor="ctr"/>
           <a:lstStyle/>
           <a:p>
-            <a:pPr algn="r" indent="0" marL="0">
+            <a:pPr marL="0" indent="0" algn="r">
               <a:buNone/>
             </a:pPr>
             <a:r>
@@ -1741,7 +1515,7 @@
         </p:nvSpPr>
         <p:spPr>
           <a:xfrm>
-            <a:off x="723882" y="2364135"/>
+            <a:off x="758386" y="2329631"/>
             <a:ext cx="911610" cy="133350"/>
           </a:xfrm>
           <a:prstGeom prst="rect">
@@ -1754,7 +1528,7 @@
           <a:bodyPr wrap="square" lIns="0" tIns="114300" rIns="114300" bIns="0" rtlCol="0" anchor="ctr"/>
           <a:lstStyle/>
           <a:p>
-            <a:pPr algn="l" indent="0" marL="0">
+            <a:pPr marL="0" indent="0" algn="l">
               <a:buNone/>
             </a:pPr>
             <a:r>
@@ -1793,7 +1567,7 @@
           <a:bodyPr wrap="square" lIns="0" tIns="114300" rIns="114300" bIns="0" rtlCol="0" anchor="ctr"/>
           <a:lstStyle/>
           <a:p>
-            <a:pPr algn="l" indent="0" marL="0">
+            <a:pPr marL="0" indent="0" algn="l">
               <a:buNone/>
             </a:pPr>
             <a:r>
@@ -1832,7 +1606,7 @@
           <a:bodyPr wrap="square" lIns="0" tIns="114300" rIns="114300" bIns="0" rtlCol="0" anchor="ctr"/>
           <a:lstStyle/>
           <a:p>
-            <a:pPr algn="r" indent="0" marL="0">
+            <a:pPr marL="0" indent="0" algn="r">
               <a:buNone/>
             </a:pPr>
             <a:r>
@@ -1871,7 +1645,7 @@
           <a:bodyPr wrap="square" lIns="0" tIns="114300" rIns="114300" bIns="0" rtlCol="0" anchor="ctr"/>
           <a:lstStyle/>
           <a:p>
-            <a:pPr algn="r" indent="0" marL="0">
+            <a:pPr marL="0" indent="0" algn="r">
               <a:buNone/>
             </a:pPr>
             <a:r>
@@ -1910,7 +1684,7 @@
           <a:bodyPr wrap="square" lIns="0" tIns="114300" rIns="114300" bIns="0" rtlCol="0" anchor="ctr"/>
           <a:lstStyle/>
           <a:p>
-            <a:pPr algn="l" indent="0" marL="0">
+            <a:pPr marL="0" indent="0" algn="l">
               <a:buNone/>
             </a:pPr>
             <a:r>
@@ -1949,7 +1723,7 @@
           <a:bodyPr wrap="square" lIns="0" tIns="114300" rIns="114300" bIns="0" rtlCol="0" anchor="ctr"/>
           <a:lstStyle/>
           <a:p>
-            <a:pPr algn="r" indent="0" marL="0">
+            <a:pPr marL="0" indent="0" algn="r">
               <a:buNone/>
             </a:pPr>
             <a:r>
@@ -1988,7 +1762,7 @@
           <a:bodyPr wrap="square" lIns="0" tIns="114300" rIns="114300" bIns="0" rtlCol="0" anchor="ctr"/>
           <a:lstStyle/>
           <a:p>
-            <a:pPr algn="r" indent="0" marL="0">
+            <a:pPr marL="0" indent="0" algn="r">
               <a:buNone/>
             </a:pPr>
             <a:r>
@@ -2027,7 +1801,7 @@
           <a:bodyPr wrap="square" lIns="0" tIns="114300" rIns="114300" bIns="0" rtlCol="0" anchor="ctr"/>
           <a:lstStyle/>
           <a:p>
-            <a:pPr algn="l" indent="0" marL="0">
+            <a:pPr marL="0" indent="0" algn="l">
               <a:buNone/>
             </a:pPr>
             <a:r>
@@ -2066,7 +1840,7 @@
           <a:bodyPr wrap="square" lIns="0" tIns="114300" rIns="114300" bIns="0" rtlCol="0" anchor="ctr"/>
           <a:lstStyle/>
           <a:p>
-            <a:pPr algn="r" indent="0" marL="0">
+            <a:pPr marL="0" indent="0" algn="r">
               <a:buNone/>
             </a:pPr>
             <a:r>
@@ -2105,7 +1879,7 @@
           <a:bodyPr wrap="square" lIns="0" tIns="114300" rIns="114300" bIns="0" rtlCol="0" anchor="ctr"/>
           <a:lstStyle/>
           <a:p>
-            <a:pPr algn="r" indent="0" marL="0">
+            <a:pPr marL="0" indent="0" algn="r">
               <a:buNone/>
             </a:pPr>
             <a:r>
@@ -2144,7 +1918,7 @@
           <a:bodyPr wrap="square" lIns="0" tIns="114300" rIns="114300" bIns="0" rtlCol="0" anchor="ctr"/>
           <a:lstStyle/>
           <a:p>
-            <a:pPr algn="l" indent="0" marL="0">
+            <a:pPr marL="0" indent="0" algn="l">
               <a:buNone/>
             </a:pPr>
             <a:r>
@@ -2183,7 +1957,7 @@
           <a:bodyPr wrap="square" lIns="0" tIns="114300" rIns="114300" bIns="0" rtlCol="0" anchor="ctr"/>
           <a:lstStyle/>
           <a:p>
-            <a:pPr algn="r" indent="0" marL="0">
+            <a:pPr marL="0" indent="0" algn="r">
               <a:buNone/>
             </a:pPr>
             <a:r>
@@ -2222,7 +1996,7 @@
           <a:bodyPr wrap="square" lIns="0" tIns="114300" rIns="114300" bIns="0" rtlCol="0" anchor="ctr"/>
           <a:lstStyle/>
           <a:p>
-            <a:pPr algn="r" indent="0" marL="0">
+            <a:pPr marL="0" indent="0" algn="r">
               <a:buNone/>
             </a:pPr>
             <a:r>
@@ -2261,7 +2035,7 @@
           <a:bodyPr wrap="square" lIns="0" tIns="114300" rIns="114300" bIns="0" rtlCol="0" anchor="ctr"/>
           <a:lstStyle/>
           <a:p>
-            <a:pPr algn="l" indent="0" marL="0">
+            <a:pPr marL="0" indent="0" algn="l">
               <a:buNone/>
             </a:pPr>
             <a:r>
@@ -2300,7 +2074,7 @@
           <a:bodyPr wrap="square" lIns="0" tIns="114300" rIns="114300" bIns="0" rtlCol="0" anchor="ctr"/>
           <a:lstStyle/>
           <a:p>
-            <a:pPr algn="r" indent="0" marL="0">
+            <a:pPr marL="0" indent="0" algn="r">
               <a:buNone/>
             </a:pPr>
             <a:r>
@@ -2339,7 +2113,7 @@
           <a:bodyPr wrap="square" lIns="0" tIns="114300" rIns="114300" bIns="0" rtlCol="0" anchor="ctr"/>
           <a:lstStyle/>
           <a:p>
-            <a:pPr algn="l" indent="0" marL="0">
+            <a:pPr marL="0" indent="0" algn="l">
               <a:buNone/>
             </a:pPr>
             <a:r>
@@ -2378,7 +2152,7 @@
           <a:bodyPr wrap="square" lIns="0" tIns="114300" rIns="114300" bIns="0" rtlCol="0" anchor="ctr"/>
           <a:lstStyle/>
           <a:p>
-            <a:pPr algn="r" indent="0" marL="0">
+            <a:pPr marL="0" indent="0" algn="r">
               <a:buNone/>
             </a:pPr>
             <a:r>
@@ -2417,7 +2191,7 @@
           <a:bodyPr wrap="square" lIns="0" tIns="114300" rIns="114300" bIns="0" rtlCol="0" anchor="ctr"/>
           <a:lstStyle/>
           <a:p>
-            <a:pPr algn="l" indent="0" marL="0">
+            <a:pPr marL="0" indent="0" algn="l">
               <a:buNone/>
             </a:pPr>
             <a:r>
@@ -2456,7 +2230,7 @@
           <a:bodyPr wrap="square" lIns="0" tIns="114300" rIns="114300" bIns="0" rtlCol="0" anchor="ctr"/>
           <a:lstStyle/>
           <a:p>
-            <a:pPr algn="r" indent="0" marL="0">
+            <a:pPr marL="0" indent="0" algn="r">
               <a:buNone/>
             </a:pPr>
             <a:r>
@@ -2495,7 +2269,7 @@
           <a:bodyPr wrap="square" lIns="0" tIns="114300" rIns="114300" bIns="0" rtlCol="0" anchor="ctr"/>
           <a:lstStyle/>
           <a:p>
-            <a:pPr algn="l" indent="0" marL="0">
+            <a:pPr marL="0" indent="0" algn="l">
               <a:buNone/>
             </a:pPr>
             <a:r>
@@ -2534,7 +2308,7 @@
           <a:bodyPr wrap="square" lIns="0" tIns="114300" rIns="114300" bIns="0" rtlCol="0" anchor="ctr"/>
           <a:lstStyle/>
           <a:p>
-            <a:pPr algn="r" indent="0" marL="0">
+            <a:pPr marL="0" indent="0" algn="r">
               <a:buNone/>
             </a:pPr>
             <a:r>
@@ -2573,7 +2347,7 @@
           <a:bodyPr wrap="square" lIns="0" tIns="114300" rIns="114300" bIns="0" rtlCol="0" anchor="ctr"/>
           <a:lstStyle/>
           <a:p>
-            <a:pPr algn="r" indent="0" marL="0">
+            <a:pPr marL="0" indent="0" algn="r">
               <a:buNone/>
             </a:pPr>
             <a:r>
@@ -2612,7 +2386,7 @@
           <a:bodyPr wrap="square" lIns="0" tIns="114300" rIns="114300" bIns="0" rtlCol="0" anchor="ctr"/>
           <a:lstStyle/>
           <a:p>
-            <a:pPr algn="r" indent="0" marL="0">
+            <a:pPr marL="0" indent="0" algn="r">
               <a:buNone/>
             </a:pPr>
             <a:r>
@@ -2651,7 +2425,7 @@
           <a:bodyPr wrap="square" lIns="0" tIns="114300" rIns="114300" bIns="0" rtlCol="0" anchor="ctr"/>
           <a:lstStyle/>
           <a:p>
-            <a:pPr algn="r" indent="0" marL="0">
+            <a:pPr marL="0" indent="0" algn="r">
               <a:buNone/>
             </a:pPr>
             <a:r>
@@ -2690,7 +2464,7 @@
           <a:bodyPr wrap="square" lIns="0" tIns="0" rIns="0" bIns="0" rtlCol="0" anchor="t"/>
           <a:lstStyle/>
           <a:p>
-            <a:pPr algn="l" indent="0" marL="0">
+            <a:pPr marL="0" indent="0" algn="l">
               <a:buNone/>
             </a:pPr>
             <a:r>
@@ -2716,7 +2490,7 @@
         </p:nvSpPr>
         <p:spPr>
           <a:xfrm>
-            <a:off x="6440849" y="2354610"/>
+            <a:off x="6409099" y="2354610"/>
             <a:ext cx="274320" cy="128016"/>
           </a:xfrm>
           <a:prstGeom prst="rect">
@@ -2729,7 +2503,7 @@
           <a:bodyPr wrap="square" lIns="0" tIns="0" rIns="0" bIns="0" rtlCol="0" anchor="t"/>
           <a:lstStyle/>
           <a:p>
-            <a:pPr algn="r" indent="0" marL="0">
+            <a:pPr marL="0" indent="0" algn="r">
               <a:buNone/>
             </a:pPr>
             <a:r>
@@ -2755,7 +2529,7 @@
         </p:nvSpPr>
         <p:spPr>
           <a:xfrm>
-            <a:off x="6443373" y="2583210"/>
+            <a:off x="6411623" y="2583210"/>
             <a:ext cx="274320" cy="128016"/>
           </a:xfrm>
           <a:prstGeom prst="rect">
@@ -2768,7 +2542,7 @@
           <a:bodyPr wrap="square" lIns="0" tIns="0" rIns="0" bIns="0" rtlCol="0" anchor="t"/>
           <a:lstStyle/>
           <a:p>
-            <a:pPr algn="r" indent="0" marL="0">
+            <a:pPr marL="0" indent="0" algn="r">
               <a:buNone/>
             </a:pPr>
             <a:r>
@@ -2794,7 +2568,7 @@
         </p:nvSpPr>
         <p:spPr>
           <a:xfrm>
-            <a:off x="6438798" y="2811810"/>
+            <a:off x="6407048" y="2811810"/>
             <a:ext cx="274320" cy="128016"/>
           </a:xfrm>
           <a:prstGeom prst="rect">
@@ -2807,7 +2581,7 @@
           <a:bodyPr wrap="square" lIns="0" tIns="0" rIns="0" bIns="0" rtlCol="0" anchor="t"/>
           <a:lstStyle/>
           <a:p>
-            <a:pPr algn="r" indent="0" marL="0">
+            <a:pPr marL="0" indent="0" algn="r">
               <a:buNone/>
             </a:pPr>
             <a:r>
@@ -2833,7 +2607,7 @@
         </p:nvSpPr>
         <p:spPr>
           <a:xfrm>
-            <a:off x="6452207" y="3040410"/>
+            <a:off x="6420457" y="3040410"/>
             <a:ext cx="274320" cy="128016"/>
           </a:xfrm>
           <a:prstGeom prst="rect">
@@ -2846,7 +2620,7 @@
           <a:bodyPr wrap="square" lIns="0" tIns="0" rIns="0" bIns="0" rtlCol="0" anchor="t"/>
           <a:lstStyle/>
           <a:p>
-            <a:pPr algn="r" indent="0" marL="0">
+            <a:pPr marL="0" indent="0" algn="r">
               <a:buNone/>
             </a:pPr>
             <a:r>
@@ -2872,7 +2646,7 @@
         </p:nvSpPr>
         <p:spPr>
           <a:xfrm>
-            <a:off x="6423811" y="3269010"/>
+            <a:off x="6392061" y="3269010"/>
             <a:ext cx="274320" cy="128016"/>
           </a:xfrm>
           <a:prstGeom prst="rect">
@@ -2885,7 +2659,7 @@
           <a:bodyPr wrap="square" lIns="0" tIns="0" rIns="0" bIns="0" rtlCol="0" anchor="t"/>
           <a:lstStyle/>
           <a:p>
-            <a:pPr algn="r" indent="0" marL="0">
+            <a:pPr marL="0" indent="0" algn="r">
               <a:buNone/>
             </a:pPr>
             <a:r>
@@ -2911,7 +2685,7 @@
         </p:nvSpPr>
         <p:spPr>
           <a:xfrm>
-            <a:off x="6450787" y="3497610"/>
+            <a:off x="6419037" y="3497610"/>
             <a:ext cx="274320" cy="128016"/>
           </a:xfrm>
           <a:prstGeom prst="rect">
@@ -2924,7 +2698,7 @@
           <a:bodyPr wrap="square" lIns="0" tIns="0" rIns="0" bIns="0" rtlCol="0" anchor="t"/>
           <a:lstStyle/>
           <a:p>
-            <a:pPr algn="r" indent="0" marL="0">
+            <a:pPr marL="0" indent="0" algn="r">
               <a:buNone/>
             </a:pPr>
             <a:r>
@@ -2950,7 +2724,7 @@
         </p:nvSpPr>
         <p:spPr>
           <a:xfrm>
-            <a:off x="6480918" y="3726210"/>
+            <a:off x="6449168" y="3726210"/>
             <a:ext cx="274320" cy="128016"/>
           </a:xfrm>
           <a:prstGeom prst="rect">
@@ -2963,7 +2737,7 @@
           <a:bodyPr wrap="square" lIns="0" tIns="0" rIns="0" bIns="0" rtlCol="0" anchor="t"/>
           <a:lstStyle/>
           <a:p>
-            <a:pPr algn="r" indent="0" marL="0">
+            <a:pPr marL="0" indent="0" algn="r">
               <a:buNone/>
             </a:pPr>
             <a:r>
@@ -2989,7 +2763,7 @@
         </p:nvSpPr>
         <p:spPr>
           <a:xfrm>
-            <a:off x="6430753" y="3954810"/>
+            <a:off x="6399003" y="3954810"/>
             <a:ext cx="274320" cy="128016"/>
           </a:xfrm>
           <a:prstGeom prst="rect">
@@ -3002,7 +2776,7 @@
           <a:bodyPr wrap="square" lIns="0" tIns="0" rIns="0" bIns="0" rtlCol="0" anchor="t"/>
           <a:lstStyle/>
           <a:p>
-            <a:pPr algn="r" indent="0" marL="0">
+            <a:pPr marL="0" indent="0" algn="r">
               <a:buNone/>
             </a:pPr>
             <a:r>
@@ -3041,7 +2815,7 @@
           <a:bodyPr wrap="square" lIns="0" tIns="114300" rIns="114300" bIns="0" rtlCol="0" anchor="ctr"/>
           <a:lstStyle/>
           <a:p>
-            <a:pPr algn="r" indent="0" marL="0">
+            <a:pPr marL="0" indent="0" algn="r">
               <a:buNone/>
             </a:pPr>
             <a:r>
@@ -3080,7 +2854,7 @@
           <a:bodyPr wrap="square" lIns="0" tIns="114300" rIns="114300" bIns="0" rtlCol="0" anchor="ctr"/>
           <a:lstStyle/>
           <a:p>
-            <a:pPr algn="r" indent="0" marL="0">
+            <a:pPr marL="0" indent="0" algn="r">
               <a:buNone/>
             </a:pPr>
             <a:r>
@@ -3119,7 +2893,7 @@
           <a:bodyPr wrap="square" lIns="0" tIns="114300" rIns="114300" bIns="0" rtlCol="0" anchor="ctr"/>
           <a:lstStyle/>
           <a:p>
-            <a:pPr algn="r" indent="0" marL="0">
+            <a:pPr marL="0" indent="0" algn="r">
               <a:buNone/>
             </a:pPr>
             <a:r>
@@ -3158,7 +2932,7 @@
           <a:bodyPr wrap="square" lIns="0" tIns="114300" rIns="114300" bIns="0" rtlCol="0" anchor="ctr"/>
           <a:lstStyle/>
           <a:p>
-            <a:pPr algn="r" indent="0" marL="0">
+            <a:pPr marL="0" indent="0" algn="r">
               <a:buNone/>
             </a:pPr>
             <a:r>
@@ -3197,7 +2971,7 @@
           <a:bodyPr wrap="square" lIns="0" tIns="114300" rIns="114300" bIns="0" rtlCol="0" anchor="ctr"/>
           <a:lstStyle/>
           <a:p>
-            <a:pPr algn="r" indent="0" marL="0">
+            <a:pPr marL="0" indent="0" algn="r">
               <a:buNone/>
             </a:pPr>
             <a:r>
@@ -3236,7 +3010,7 @@
           <a:bodyPr wrap="square" lIns="0" tIns="114300" rIns="114300" bIns="0" rtlCol="0" anchor="ctr"/>
           <a:lstStyle/>
           <a:p>
-            <a:pPr algn="r" indent="0" marL="0">
+            <a:pPr marL="0" indent="0" algn="r">
               <a:buNone/>
             </a:pPr>
             <a:r>
@@ -3275,7 +3049,7 @@
           <a:bodyPr wrap="square" lIns="0" tIns="114300" rIns="114300" bIns="0" rtlCol="0" anchor="ctr"/>
           <a:lstStyle/>
           <a:p>
-            <a:pPr algn="r" indent="0" marL="0">
+            <a:pPr marL="0" indent="0" algn="r">
               <a:buNone/>
             </a:pPr>
             <a:r>
@@ -3314,7 +3088,7 @@
           <a:bodyPr wrap="square" lIns="0" tIns="114300" rIns="114300" bIns="0" rtlCol="0" anchor="ctr"/>
           <a:lstStyle/>
           <a:p>
-            <a:pPr algn="r" indent="0" marL="0">
+            <a:pPr marL="0" indent="0" algn="r">
               <a:buNone/>
             </a:pPr>
             <a:r>
@@ -3353,7 +3127,7 @@
           <a:bodyPr wrap="square" lIns="0" tIns="114300" rIns="114300" bIns="0" rtlCol="0" anchor="ctr"/>
           <a:lstStyle/>
           <a:p>
-            <a:pPr algn="r" indent="0" marL="0">
+            <a:pPr marL="0" indent="0" algn="r">
               <a:buNone/>
             </a:pPr>
             <a:r>
@@ -3392,7 +3166,7 @@
           <a:bodyPr wrap="square" lIns="0" tIns="114300" rIns="114300" bIns="0" rtlCol="0" anchor="ctr"/>
           <a:lstStyle/>
           <a:p>
-            <a:pPr algn="r" indent="0" marL="0">
+            <a:pPr marL="0" indent="0" algn="r">
               <a:buNone/>
             </a:pPr>
             <a:r>
@@ -3431,7 +3205,7 @@
           <a:bodyPr wrap="square" lIns="0" tIns="114300" rIns="114300" bIns="0" rtlCol="0" anchor="ctr"/>
           <a:lstStyle/>
           <a:p>
-            <a:pPr algn="r" indent="0" marL="0">
+            <a:pPr marL="0" indent="0" algn="r">
               <a:buNone/>
             </a:pPr>
             <a:r>
@@ -3470,7 +3244,7 @@
           <a:bodyPr wrap="square" lIns="0" tIns="114300" rIns="114300" bIns="0" rtlCol="0" anchor="ctr"/>
           <a:lstStyle/>
           <a:p>
-            <a:pPr algn="r" indent="0" marL="0">
+            <a:pPr marL="0" indent="0" algn="r">
               <a:buNone/>
             </a:pPr>
             <a:r>
@@ -3509,7 +3283,7 @@
           <a:bodyPr wrap="square" lIns="0" tIns="114300" rIns="114300" bIns="0" rtlCol="0" anchor="ctr"/>
           <a:lstStyle/>
           <a:p>
-            <a:pPr algn="r" indent="0" marL="0">
+            <a:pPr marL="0" indent="0" algn="r">
               <a:buNone/>
             </a:pPr>
             <a:r>
@@ -3548,7 +3322,7 @@
           <a:bodyPr wrap="square" lIns="0" tIns="114300" rIns="114300" bIns="0" rtlCol="0" anchor="ctr"/>
           <a:lstStyle/>
           <a:p>
-            <a:pPr algn="r" indent="0" marL="0">
+            <a:pPr marL="0" indent="0" algn="r">
               <a:buNone/>
             </a:pPr>
             <a:r>
@@ -3587,7 +3361,7 @@
           <a:bodyPr wrap="square" lIns="0" tIns="114300" rIns="114300" bIns="0" rtlCol="0" anchor="ctr"/>
           <a:lstStyle/>
           <a:p>
-            <a:pPr algn="r" indent="0" marL="0">
+            <a:pPr marL="0" indent="0" algn="r">
               <a:buNone/>
             </a:pPr>
             <a:r>
@@ -3626,7 +3400,7 @@
           <a:bodyPr wrap="square" lIns="0" tIns="114300" rIns="114300" bIns="0" rtlCol="0" anchor="ctr"/>
           <a:lstStyle/>
           <a:p>
-            <a:pPr algn="r" indent="0" marL="0">
+            <a:pPr marL="0" indent="0" algn="r">
               <a:buNone/>
             </a:pPr>
             <a:r>
@@ -3665,7 +3439,7 @@
           <a:bodyPr wrap="square" lIns="0" tIns="114300" rIns="114300" bIns="0" rtlCol="0" anchor="ctr"/>
           <a:lstStyle/>
           <a:p>
-            <a:pPr algn="r" indent="0" marL="0">
+            <a:pPr marL="0" indent="0" algn="r">
               <a:buNone/>
             </a:pPr>
             <a:r>
@@ -3704,7 +3478,7 @@
           <a:bodyPr wrap="square" lIns="0" tIns="114300" rIns="114300" bIns="0" rtlCol="0" anchor="ctr"/>
           <a:lstStyle/>
           <a:p>
-            <a:pPr algn="r" indent="0" marL="0">
+            <a:pPr marL="0" indent="0" algn="r">
               <a:buNone/>
             </a:pPr>
             <a:r>
@@ -3743,7 +3517,7 @@
           <a:bodyPr wrap="square" lIns="0" tIns="114300" rIns="114300" bIns="0" rtlCol="0" anchor="ctr"/>
           <a:lstStyle/>
           <a:p>
-            <a:pPr algn="r" indent="0" marL="0">
+            <a:pPr marL="0" indent="0" algn="r">
               <a:buNone/>
             </a:pPr>
             <a:r>
@@ -3782,7 +3556,7 @@
           <a:bodyPr wrap="square" lIns="0" tIns="114300" rIns="114300" bIns="0" rtlCol="0" anchor="ctr"/>
           <a:lstStyle/>
           <a:p>
-            <a:pPr algn="r" indent="0" marL="0">
+            <a:pPr marL="0" indent="0" algn="r">
               <a:buNone/>
             </a:pPr>
             <a:r>
@@ -3821,7 +3595,7 @@
           <a:bodyPr wrap="square" lIns="0" tIns="0" rIns="0" bIns="0" rtlCol="0" anchor="t"/>
           <a:lstStyle/>
           <a:p>
-            <a:pPr algn="r" indent="0" marL="0">
+            <a:pPr marL="0" indent="0" algn="r">
               <a:buNone/>
             </a:pPr>
             <a:r>
@@ -3860,7 +3634,7 @@
           <a:bodyPr wrap="square" lIns="0" tIns="0" rIns="0" bIns="0" rtlCol="0" anchor="t"/>
           <a:lstStyle/>
           <a:p>
-            <a:pPr algn="r" indent="0" marL="0">
+            <a:pPr marL="0" indent="0" algn="r">
               <a:buNone/>
             </a:pPr>
             <a:r>
@@ -3899,7 +3673,7 @@
           <a:bodyPr wrap="square" lIns="0" tIns="0" rIns="0" bIns="0" rtlCol="0" anchor="t"/>
           <a:lstStyle/>
           <a:p>
-            <a:pPr algn="r" indent="0" marL="0">
+            <a:pPr marL="0" indent="0" algn="r">
               <a:buNone/>
             </a:pPr>
             <a:r>
@@ -3938,7 +3712,7 @@
           <a:bodyPr wrap="square" lIns="0" tIns="0" rIns="0" bIns="0" rtlCol="0" anchor="t"/>
           <a:lstStyle/>
           <a:p>
-            <a:pPr algn="r" indent="0" marL="0">
+            <a:pPr marL="0" indent="0" algn="r">
               <a:buNone/>
             </a:pPr>
             <a:r>
@@ -3977,7 +3751,7 @@
           <a:bodyPr wrap="square" lIns="0" tIns="0" rIns="0" bIns="0" rtlCol="0" anchor="t"/>
           <a:lstStyle/>
           <a:p>
-            <a:pPr algn="r" indent="0" marL="0">
+            <a:pPr marL="0" indent="0" algn="r">
               <a:buNone/>
             </a:pPr>
             <a:r>
@@ -4016,7 +3790,7 @@
           <a:bodyPr wrap="square" lIns="0" tIns="0" rIns="0" bIns="0" rtlCol="0" anchor="t"/>
           <a:lstStyle/>
           <a:p>
-            <a:pPr algn="r" indent="0" marL="0">
+            <a:pPr marL="0" indent="0" algn="r">
               <a:buNone/>
             </a:pPr>
             <a:r>
@@ -4055,7 +3829,7 @@
           <a:bodyPr wrap="square" lIns="0" tIns="0" rIns="0" bIns="0" rtlCol="0" anchor="t"/>
           <a:lstStyle/>
           <a:p>
-            <a:pPr algn="r" indent="0" marL="0">
+            <a:pPr marL="0" indent="0" algn="r">
               <a:buNone/>
             </a:pPr>
             <a:r>
@@ -4094,7 +3868,7 @@
           <a:bodyPr wrap="square" lIns="0" tIns="0" rIns="0" bIns="0" rtlCol="0" anchor="t"/>
           <a:lstStyle/>
           <a:p>
-            <a:pPr algn="r" indent="0" marL="0">
+            <a:pPr marL="0" indent="0" algn="r">
               <a:buNone/>
             </a:pPr>
             <a:r>
@@ -4139,14 +3913,14 @@
       </p:grpSpPr>
       <p:pic>
         <p:nvPicPr>
-          <p:cNvPr id="2" name="Image 0" descr="C:\01_Repositorios\02_CRM\02_Informe_Semetral\dash\retail\ppt_slides\sk_01_main.png">    </p:cNvPr>
+          <p:cNvPr id="2" name="Image 0" descr="C:\01_Repositorios\02_CRM\02_Informe_Semetral\dash\retail\ppt_slides\sk_01_main.png"/>
           <p:cNvPicPr>
             <a:picLocks noChangeAspect="1"/>
           </p:cNvPicPr>
           <p:nvPr/>
         </p:nvPicPr>
         <p:blipFill>
-          <a:blip r:embed="rId1"/>
+          <a:blip r:embed="rId3"/>
           <a:stretch>
             <a:fillRect/>
           </a:stretch>
@@ -4182,7 +3956,7 @@
           <a:bodyPr wrap="square" lIns="0" tIns="0" rIns="0" bIns="0" rtlCol="0" anchor="t"/>
           <a:lstStyle/>
           <a:p>
-            <a:pPr algn="l" indent="0" marL="0">
+            <a:pPr marL="0" indent="0" algn="l">
               <a:buNone/>
             </a:pPr>
             <a:r>
@@ -4196,9 +3970,6 @@
               </a:rPr>
               <a:t>* Universo = PDV físicos distintos observados en los cortes semanales "Como vamos" de Ene-Ago. Coberturas &gt;100 % indican PDV que Formación visitó con nombre distinto al registrado en Como vamos ese corte, o puntos sin gestión comercial activa ese mes. </a:t>
             </a:r>
-            <a:pPr algn="l" indent="0" marL="0">
-              <a:buNone/>
-            </a:pPr>
             <a:r>
               <a:rPr lang="en-US" sz="720" b="1" dirty="0">
                 <a:solidFill>
@@ -4210,9 +3981,6 @@
               </a:rPr>
               <a:t>Gestores del canal:</a:t>
             </a:r>
-            <a:pPr algn="l" indent="0" marL="0">
-              <a:buNone/>
-            </a:pPr>
             <a:r>
               <a:rPr lang="en-US" sz="720" dirty="0">
                 <a:solidFill>
@@ -4249,7 +4017,7 @@
           <a:bodyPr wrap="square" lIns="0" tIns="0" rIns="0" bIns="0" rtlCol="0" anchor="t"/>
           <a:lstStyle/>
           <a:p>
-            <a:pPr algn="l" indent="0" marL="0">
+            <a:pPr marL="0" indent="0" algn="l">
               <a:buNone/>
             </a:pPr>
             <a:r>
@@ -4263,9 +4031,6 @@
               </a:rPr>
               <a:t>Sobre "Serdán" (103 visitas):</a:t>
             </a:r>
-            <a:pPr algn="l" indent="0" marL="0">
-              <a:buNone/>
-            </a:pPr>
             <a:r>
               <a:rPr lang="en-US" sz="720" dirty="0">
                 <a:solidFill>
@@ -4277,9 +4042,6 @@
               </a:rPr>
               <a:t> empresa que provee promotores a ambos canales, no un aliado. De las 103: 48 puras Retail+Tradicional, 39 sedes/roles internos (no PDV), 15 con cédula activa en ambos canales </a:t>
             </a:r>
-            <a:pPr algn="l" indent="0" marL="0">
-              <a:buNone/>
-            </a:pPr>
             <a:r>
               <a:rPr lang="en-US" sz="720" b="1" dirty="0">
                 <a:solidFill>
@@ -4291,9 +4053,6 @@
               </a:rPr>
               <a:t>(contadas en los dos)</a:t>
             </a:r>
-            <a:pPr algn="l" indent="0" marL="0">
-              <a:buNone/>
-            </a:pPr>
             <a:r>
               <a:rPr lang="en-US" sz="720" dirty="0">
                 <a:solidFill>
@@ -4305,9 +4064,6 @@
               </a:rPr>
               <a:t> y 1 sin clasificar. Total atribuido: </a:t>
             </a:r>
-            <a:pPr algn="l" indent="0" marL="0">
-              <a:buNone/>
-            </a:pPr>
             <a:r>
               <a:rPr lang="en-US" sz="720" b="1" dirty="0">
                 <a:solidFill>
@@ -4319,9 +4075,6 @@
               </a:rPr>
               <a:t>24 a Retail</a:t>
             </a:r>
-            <a:pPr algn="l" indent="0" marL="0">
-              <a:buNone/>
-            </a:pPr>
             <a:r>
               <a:rPr lang="en-US" sz="720" dirty="0">
                 <a:solidFill>
@@ -4333,9 +4086,6 @@
               </a:rPr>
               <a:t> y </a:t>
             </a:r>
-            <a:pPr algn="l" indent="0" marL="0">
-              <a:buNone/>
-            </a:pPr>
             <a:r>
               <a:rPr lang="en-US" sz="720" b="1" dirty="0">
                 <a:solidFill>
@@ -4347,9 +4097,6 @@
               </a:rPr>
               <a:t>54 a Tradicional</a:t>
             </a:r>
-            <a:pPr algn="l" indent="0" marL="0">
-              <a:buNone/>
-            </a:pPr>
             <a:r>
               <a:rPr lang="en-US" sz="720" dirty="0">
                 <a:solidFill>
@@ -4386,7 +4133,7 @@
           <a:bodyPr wrap="square" lIns="0" tIns="0" rIns="0" bIns="0" rtlCol="0" anchor="t"/>
           <a:lstStyle/>
           <a:p>
-            <a:pPr algn="l" indent="0" marL="0">
+            <a:pPr marL="0" indent="0" algn="l">
               <a:buNone/>
             </a:pPr>
             <a:r>
@@ -4425,7 +4172,7 @@
           <a:bodyPr wrap="square" lIns="0" tIns="0" rIns="0" bIns="0" rtlCol="0" anchor="t"/>
           <a:lstStyle/>
           <a:p>
-            <a:pPr algn="l" indent="0" marL="0">
+            <a:pPr marL="0" indent="0" algn="l">
               <a:buNone/>
             </a:pPr>
             <a:r>
@@ -4464,7 +4211,7 @@
           <a:bodyPr wrap="square" lIns="0" tIns="0" rIns="0" bIns="0" rtlCol="0" anchor="t"/>
           <a:lstStyle/>
           <a:p>
-            <a:pPr algn="l" indent="0" marL="0">
+            <a:pPr marL="0" indent="0" algn="l">
               <a:buNone/>
             </a:pPr>
             <a:r>
@@ -4503,7 +4250,7 @@
           <a:bodyPr wrap="square" lIns="0" tIns="0" rIns="0" bIns="0" rtlCol="0" anchor="t"/>
           <a:lstStyle/>
           <a:p>
-            <a:pPr algn="l" indent="0" marL="0">
+            <a:pPr marL="0" indent="0" algn="l">
               <a:buNone/>
             </a:pPr>
             <a:r>
@@ -4542,7 +4289,7 @@
           <a:bodyPr wrap="square" lIns="0" tIns="0" rIns="0" bIns="0" rtlCol="0" anchor="t"/>
           <a:lstStyle/>
           <a:p>
-            <a:pPr algn="l" indent="0" marL="0">
+            <a:pPr marL="0" indent="0" algn="l">
               <a:buNone/>
             </a:pPr>
             <a:r>
@@ -4581,7 +4328,7 @@
           <a:bodyPr wrap="square" lIns="0" tIns="0" rIns="0" bIns="0" rtlCol="0" anchor="t"/>
           <a:lstStyle/>
           <a:p>
-            <a:pPr algn="l" indent="0" marL="0">
+            <a:pPr marL="0" indent="0" algn="l">
               <a:buNone/>
             </a:pPr>
             <a:r>
@@ -4620,7 +4367,7 @@
           <a:bodyPr wrap="square" lIns="0" tIns="0" rIns="0" bIns="0" rtlCol="0" anchor="t"/>
           <a:lstStyle/>
           <a:p>
-            <a:pPr algn="l" indent="0" marL="0">
+            <a:pPr marL="0" indent="0" algn="l">
               <a:buNone/>
             </a:pPr>
             <a:r>
@@ -4659,7 +4406,7 @@
           <a:bodyPr wrap="square" lIns="0" tIns="114300" rIns="114300" bIns="0" rtlCol="0" anchor="ctr"/>
           <a:lstStyle/>
           <a:p>
-            <a:pPr algn="l" indent="0" marL="0">
+            <a:pPr marL="0" indent="0" algn="l">
               <a:buNone/>
             </a:pPr>
             <a:r>
@@ -4673,9 +4420,6 @@
               </a:rPr>
               <a:t>Colombiana de Comercio</a:t>
             </a:r>
-            <a:pPr algn="l" indent="0" marL="0">
-              <a:buNone/>
-            </a:pPr>
             <a:r>
               <a:rPr lang="en-US" sz="888" dirty="0">
                 <a:solidFill>
@@ -4712,7 +4456,7 @@
           <a:bodyPr wrap="square" lIns="0" tIns="114300" rIns="114300" bIns="0" rtlCol="0" anchor="ctr"/>
           <a:lstStyle/>
           <a:p>
-            <a:pPr algn="l" indent="0" marL="0">
+            <a:pPr marL="0" indent="0" algn="l">
               <a:buNone/>
             </a:pPr>
             <a:r>
@@ -4726,9 +4470,6 @@
               </a:rPr>
               <a:t>Olímpica </a:t>
             </a:r>
-            <a:pPr algn="l" indent="0" marL="0">
-              <a:buNone/>
-            </a:pPr>
             <a:r>
               <a:rPr lang="en-US" sz="696" b="1" dirty="0">
                 <a:solidFill>
@@ -4765,7 +4506,7 @@
           <a:bodyPr wrap="square" lIns="0" tIns="0" rIns="0" bIns="0" rtlCol="0" anchor="t"/>
           <a:lstStyle/>
           <a:p>
-            <a:pPr algn="l" indent="0" marL="0">
+            <a:pPr marL="0" indent="0" algn="l">
               <a:buNone/>
             </a:pPr>
             <a:r>
@@ -4804,7 +4545,7 @@
           <a:bodyPr wrap="square" lIns="0" tIns="114300" rIns="114300" bIns="0" rtlCol="0" anchor="ctr"/>
           <a:lstStyle/>
           <a:p>
-            <a:pPr algn="l" indent="0" marL="0">
+            <a:pPr marL="0" indent="0" algn="l">
               <a:buNone/>
             </a:pPr>
             <a:r>
@@ -4818,9 +4559,6 @@
               </a:rPr>
               <a:t>Almacenes Éxito </a:t>
             </a:r>
-            <a:pPr algn="l" indent="0" marL="0">
-              <a:buNone/>
-            </a:pPr>
             <a:r>
               <a:rPr lang="en-US" sz="696" b="1" dirty="0">
                 <a:solidFill>
@@ -4857,7 +4595,7 @@
           <a:bodyPr wrap="square" lIns="0" tIns="0" rIns="0" bIns="0" rtlCol="0" anchor="t"/>
           <a:lstStyle/>
           <a:p>
-            <a:pPr algn="l" indent="0" marL="0">
+            <a:pPr marL="0" indent="0" algn="l">
               <a:buNone/>
             </a:pPr>
             <a:r>
@@ -4896,7 +4634,7 @@
           <a:bodyPr wrap="square" lIns="0" tIns="0" rIns="0" bIns="0" rtlCol="0" anchor="t"/>
           <a:lstStyle/>
           <a:p>
-            <a:pPr algn="l" indent="0" marL="0">
+            <a:pPr marL="0" indent="0" algn="l">
               <a:buNone/>
             </a:pPr>
             <a:r>
@@ -4935,7 +4673,7 @@
           <a:bodyPr wrap="square" lIns="0" tIns="0" rIns="0" bIns="0" rtlCol="0" anchor="t"/>
           <a:lstStyle/>
           <a:p>
-            <a:pPr algn="l" indent="0" marL="0">
+            <a:pPr marL="0" indent="0" algn="l">
               <a:buNone/>
             </a:pPr>
             <a:r>
@@ -4974,7 +4712,7 @@
           <a:bodyPr wrap="square" lIns="0" tIns="0" rIns="0" bIns="0" rtlCol="0" anchor="t"/>
           <a:lstStyle/>
           <a:p>
-            <a:pPr algn="l" indent="0" marL="0">
+            <a:pPr marL="0" indent="0" algn="l">
               <a:buNone/>
             </a:pPr>
             <a:r>
@@ -5013,7 +4751,7 @@
           <a:bodyPr wrap="square" lIns="0" tIns="114300" rIns="114300" bIns="0" rtlCol="0" anchor="ctr"/>
           <a:lstStyle/>
           <a:p>
-            <a:pPr algn="l" indent="0" marL="0">
+            <a:pPr marL="0" indent="0" algn="l">
               <a:buNone/>
             </a:pPr>
             <a:r>
@@ -5027,9 +4765,6 @@
               </a:rPr>
               <a:t>Cencosud</a:t>
             </a:r>
-            <a:pPr algn="l" indent="0" marL="0">
-              <a:buNone/>
-            </a:pPr>
             <a:r>
               <a:rPr lang="en-US" sz="888" dirty="0">
                 <a:solidFill>
@@ -5066,7 +4801,7 @@
           <a:bodyPr wrap="square" lIns="0" tIns="0" rIns="0" bIns="0" rtlCol="0" anchor="t"/>
           <a:lstStyle/>
           <a:p>
-            <a:pPr algn="l" indent="0" marL="0">
+            <a:pPr marL="0" indent="0" algn="l">
               <a:buNone/>
             </a:pPr>
             <a:r>
@@ -5105,7 +4840,7 @@
           <a:bodyPr wrap="square" lIns="0" tIns="0" rIns="0" bIns="0" rtlCol="0" anchor="t"/>
           <a:lstStyle/>
           <a:p>
-            <a:pPr algn="l" indent="0" marL="0">
+            <a:pPr marL="0" indent="0" algn="l">
               <a:buNone/>
             </a:pPr>
             <a:r>
@@ -5144,7 +4879,7 @@
           <a:bodyPr wrap="square" lIns="0" tIns="0" rIns="0" bIns="0" rtlCol="0" anchor="t"/>
           <a:lstStyle/>
           <a:p>
-            <a:pPr algn="l" indent="0" marL="0">
+            <a:pPr marL="0" indent="0" algn="l">
               <a:buNone/>
             </a:pPr>
             <a:r>
@@ -5183,7 +4918,7 @@
           <a:bodyPr wrap="square" lIns="0" tIns="114300" rIns="114300" bIns="0" rtlCol="0" anchor="ctr"/>
           <a:lstStyle/>
           <a:p>
-            <a:pPr algn="l" indent="0" marL="0">
+            <a:pPr marL="0" indent="0" algn="l">
               <a:buNone/>
             </a:pPr>
             <a:r>
@@ -5209,7 +4944,7 @@
         </p:nvSpPr>
         <p:spPr>
           <a:xfrm>
-            <a:off x="2544372" y="2038052"/>
+            <a:off x="2561624" y="1994922"/>
             <a:ext cx="1234131" cy="133350"/>
           </a:xfrm>
           <a:prstGeom prst="rect">
@@ -5222,7 +4957,7 @@
           <a:bodyPr wrap="square" lIns="0" tIns="114300" rIns="114300" bIns="0" rtlCol="0" anchor="ctr"/>
           <a:lstStyle/>
           <a:p>
-            <a:pPr algn="r" indent="0" marL="0">
+            <a:pPr marL="0" indent="0" algn="r">
               <a:buNone/>
             </a:pPr>
             <a:r>
@@ -5248,7 +4983,7 @@
         </p:nvSpPr>
         <p:spPr>
           <a:xfrm>
-            <a:off x="3745683" y="2038052"/>
+            <a:off x="3762935" y="1994922"/>
             <a:ext cx="1126828" cy="133350"/>
           </a:xfrm>
           <a:prstGeom prst="rect">
@@ -5261,7 +4996,7 @@
           <a:bodyPr wrap="square" lIns="0" tIns="114300" rIns="114300" bIns="0" rtlCol="0" anchor="ctr"/>
           <a:lstStyle/>
           <a:p>
-            <a:pPr algn="r" indent="0" marL="0">
+            <a:pPr marL="0" indent="0" algn="r">
               <a:buNone/>
             </a:pPr>
             <a:r>
@@ -5288,19 +5023,19 @@
         <p:spPr>
           <a:xfrm>
             <a:off x="704832" y="4238327"/>
-            <a:ext cx="858572" cy="266700"/>
-          </a:xfrm>
-          <a:prstGeom prst="rect">
-            <a:avLst/>
-          </a:prstGeom>
-          <a:noFill/>
-          <a:ln/>
-        </p:spPr>
-        <p:txBody>
-          <a:bodyPr wrap="square" lIns="0" tIns="114300" rIns="114300" bIns="0" rtlCol="0" anchor="ctr"/>
-          <a:lstStyle/>
-          <a:p>
-            <a:pPr algn="l" indent="0" marL="0">
+            <a:ext cx="926754" cy="266700"/>
+          </a:xfrm>
+          <a:prstGeom prst="rect">
+            <a:avLst/>
+          </a:prstGeom>
+          <a:noFill/>
+          <a:ln/>
+        </p:spPr>
+        <p:txBody>
+          <a:bodyPr wrap="square" lIns="0" tIns="114300" rIns="114300" bIns="0" rtlCol="0" anchor="ctr"/>
+          <a:lstStyle/>
+          <a:p>
+            <a:pPr marL="0" indent="0" algn="l">
               <a:buNone/>
             </a:pPr>
             <a:r>
@@ -5339,7 +5074,7 @@
           <a:bodyPr wrap="square" lIns="0" tIns="114300" rIns="114300" bIns="0" rtlCol="0" anchor="ctr"/>
           <a:lstStyle/>
           <a:p>
-            <a:pPr algn="r" indent="0" marL="0">
+            <a:pPr marL="0" indent="0" algn="r">
               <a:buNone/>
             </a:pPr>
             <a:r>
@@ -5378,7 +5113,7 @@
           <a:bodyPr wrap="square" lIns="0" tIns="114300" rIns="114300" bIns="0" rtlCol="0" anchor="ctr"/>
           <a:lstStyle/>
           <a:p>
-            <a:pPr algn="r" indent="0" marL="0">
+            <a:pPr marL="0" indent="0" algn="r">
               <a:buNone/>
             </a:pPr>
             <a:r>
@@ -5417,7 +5152,7 @@
           <a:bodyPr wrap="square" lIns="0" tIns="114300" rIns="114300" bIns="0" rtlCol="0" anchor="ctr"/>
           <a:lstStyle/>
           <a:p>
-            <a:pPr algn="l" indent="0" marL="0">
+            <a:pPr marL="0" indent="0" algn="l">
               <a:buNone/>
             </a:pPr>
             <a:r>
@@ -5456,7 +5191,7 @@
           <a:bodyPr wrap="square" lIns="0" tIns="0" rIns="0" bIns="0" rtlCol="0" anchor="t"/>
           <a:lstStyle/>
           <a:p>
-            <a:pPr algn="l" indent="0" marL="0">
+            <a:pPr marL="0" indent="0" algn="l">
               <a:buNone/>
             </a:pPr>
             <a:r>
@@ -5495,7 +5230,7 @@
           <a:bodyPr wrap="square" lIns="0" tIns="114300" rIns="114300" bIns="0" rtlCol="0" anchor="ctr"/>
           <a:lstStyle/>
           <a:p>
-            <a:pPr algn="l" indent="0" marL="0">
+            <a:pPr marL="0" indent="0" algn="l">
               <a:buNone/>
             </a:pPr>
             <a:r>
@@ -5521,7 +5256,7 @@
         </p:nvSpPr>
         <p:spPr>
           <a:xfrm>
-            <a:off x="4841240" y="2038052"/>
+            <a:off x="4858492" y="1994922"/>
             <a:ext cx="1073637" cy="133350"/>
           </a:xfrm>
           <a:prstGeom prst="rect">
@@ -5534,7 +5269,7 @@
           <a:bodyPr wrap="square" lIns="0" tIns="114300" rIns="114300" bIns="0" rtlCol="0" anchor="ctr"/>
           <a:lstStyle/>
           <a:p>
-            <a:pPr algn="r" indent="0" marL="0">
+            <a:pPr marL="0" indent="0" algn="r">
               <a:buNone/>
             </a:pPr>
             <a:r>
@@ -5573,7 +5308,7 @@
           <a:bodyPr wrap="square" lIns="0" tIns="114300" rIns="114300" bIns="0" rtlCol="0" anchor="ctr"/>
           <a:lstStyle/>
           <a:p>
-            <a:pPr algn="l" indent="0" marL="0">
+            <a:pPr marL="0" indent="0" algn="l">
               <a:buNone/>
             </a:pPr>
             <a:r>
@@ -5612,7 +5347,7 @@
           <a:bodyPr wrap="square" lIns="0" tIns="114300" rIns="114300" bIns="0" rtlCol="0" anchor="ctr"/>
           <a:lstStyle/>
           <a:p>
-            <a:pPr algn="l" indent="0" marL="0">
+            <a:pPr marL="0" indent="0" algn="l">
               <a:buNone/>
             </a:pPr>
             <a:r>
@@ -5651,7 +5386,7 @@
           <a:bodyPr wrap="square" lIns="0" tIns="0" rIns="0" bIns="0" rtlCol="0" anchor="t"/>
           <a:lstStyle/>
           <a:p>
-            <a:pPr algn="ctr" indent="0" marL="0">
+            <a:pPr marL="0" indent="0" algn="ctr">
               <a:buNone/>
             </a:pPr>
             <a:r>
@@ -5690,7 +5425,7 @@
           <a:bodyPr wrap="square" lIns="0" tIns="0" rIns="0" bIns="0" rtlCol="0" anchor="t"/>
           <a:lstStyle/>
           <a:p>
-            <a:pPr algn="ctr" indent="0" marL="0">
+            <a:pPr marL="0" indent="0" algn="ctr">
               <a:buNone/>
             </a:pPr>
             <a:r>
@@ -5729,7 +5464,7 @@
           <a:bodyPr wrap="square" lIns="0" tIns="114300" rIns="114300" bIns="0" rtlCol="0" anchor="ctr"/>
           <a:lstStyle/>
           <a:p>
-            <a:pPr algn="l" indent="0" marL="0">
+            <a:pPr marL="0" indent="0" algn="l">
               <a:buNone/>
             </a:pPr>
             <a:r>
@@ -5768,7 +5503,7 @@
           <a:bodyPr wrap="square" lIns="0" tIns="114300" rIns="114300" bIns="0" rtlCol="0" anchor="ctr"/>
           <a:lstStyle/>
           <a:p>
-            <a:pPr algn="l" indent="0" marL="0">
+            <a:pPr marL="0" indent="0" algn="l">
               <a:buNone/>
             </a:pPr>
             <a:r>
@@ -5807,7 +5542,7 @@
           <a:bodyPr wrap="square" lIns="0" tIns="0" rIns="0" bIns="0" rtlCol="0" anchor="t"/>
           <a:lstStyle/>
           <a:p>
-            <a:pPr algn="ctr" indent="0" marL="0">
+            <a:pPr marL="0" indent="0" algn="ctr">
               <a:buNone/>
             </a:pPr>
             <a:r>
@@ -5846,7 +5581,7 @@
           <a:bodyPr wrap="square" lIns="0" tIns="0" rIns="0" bIns="0" rtlCol="0" anchor="t"/>
           <a:lstStyle/>
           <a:p>
-            <a:pPr algn="ctr" indent="0" marL="0">
+            <a:pPr marL="0" indent="0" algn="ctr">
               <a:buNone/>
             </a:pPr>
             <a:r>
@@ -5885,7 +5620,7 @@
           <a:bodyPr wrap="square" lIns="0" tIns="114300" rIns="114300" bIns="0" rtlCol="0" anchor="ctr"/>
           <a:lstStyle/>
           <a:p>
-            <a:pPr algn="r" indent="0" marL="0">
+            <a:pPr marL="0" indent="0" algn="r">
               <a:buNone/>
             </a:pPr>
             <a:r>
@@ -5924,7 +5659,7 @@
           <a:bodyPr wrap="square" lIns="0" tIns="114300" rIns="114300" bIns="0" rtlCol="0" anchor="ctr"/>
           <a:lstStyle/>
           <a:p>
-            <a:pPr algn="l" indent="0" marL="0">
+            <a:pPr marL="0" indent="0" algn="l">
               <a:buNone/>
             </a:pPr>
             <a:r>
@@ -5963,7 +5698,7 @@
           <a:bodyPr wrap="square" lIns="0" tIns="0" rIns="0" bIns="0" rtlCol="0" anchor="t"/>
           <a:lstStyle/>
           <a:p>
-            <a:pPr algn="ctr" indent="0" marL="0">
+            <a:pPr marL="0" indent="0" algn="ctr">
               <a:buNone/>
             </a:pPr>
             <a:r>
@@ -5989,7 +5724,7 @@
         </p:nvSpPr>
         <p:spPr>
           <a:xfrm>
-            <a:off x="1507140" y="2038052"/>
+            <a:off x="1524392" y="1994922"/>
             <a:ext cx="1073177" cy="133350"/>
           </a:xfrm>
           <a:prstGeom prst="rect">
@@ -6002,7 +5737,7 @@
           <a:bodyPr wrap="square" lIns="0" tIns="114300" rIns="114300" bIns="0" rtlCol="0" anchor="ctr"/>
           <a:lstStyle/>
           <a:p>
-            <a:pPr algn="r" indent="0" marL="0">
+            <a:pPr marL="0" indent="0" algn="r">
               <a:buNone/>
             </a:pPr>
             <a:r>
@@ -6041,7 +5776,7 @@
           <a:bodyPr wrap="square" lIns="0" tIns="114300" rIns="114300" bIns="0" rtlCol="0" anchor="ctr"/>
           <a:lstStyle/>
           <a:p>
-            <a:pPr algn="l" indent="0" marL="0">
+            <a:pPr marL="0" indent="0" algn="l">
               <a:buNone/>
             </a:pPr>
             <a:r>
@@ -6080,7 +5815,7 @@
           <a:bodyPr wrap="square" lIns="0" tIns="114300" rIns="114300" bIns="0" rtlCol="0" anchor="ctr"/>
           <a:lstStyle/>
           <a:p>
-            <a:pPr algn="l" indent="0" marL="0">
+            <a:pPr marL="0" indent="0" algn="l">
               <a:buNone/>
             </a:pPr>
             <a:r>
@@ -6119,7 +5854,7 @@
           <a:bodyPr wrap="square" lIns="0" tIns="114300" rIns="114300" bIns="0" rtlCol="0" anchor="ctr"/>
           <a:lstStyle/>
           <a:p>
-            <a:pPr algn="r" indent="0" marL="0">
+            <a:pPr marL="0" indent="0" algn="r">
               <a:buNone/>
             </a:pPr>
             <a:r>
@@ -6158,7 +5893,7 @@
           <a:bodyPr wrap="square" lIns="0" tIns="114300" rIns="114300" bIns="0" rtlCol="0" anchor="ctr"/>
           <a:lstStyle/>
           <a:p>
-            <a:pPr algn="l" indent="0" marL="0">
+            <a:pPr marL="0" indent="0" algn="l">
               <a:buNone/>
             </a:pPr>
             <a:r>
@@ -6184,7 +5919,7 @@
         </p:nvSpPr>
         <p:spPr>
           <a:xfrm>
-            <a:off x="9992957" y="2153543"/>
+            <a:off x="9949827" y="2093160"/>
             <a:ext cx="853514" cy="123825"/>
           </a:xfrm>
           <a:prstGeom prst="rect">
@@ -6197,7 +5932,7 @@
           <a:bodyPr wrap="square" lIns="0" tIns="114300" rIns="114300" bIns="0" rtlCol="0" anchor="ctr"/>
           <a:lstStyle/>
           <a:p>
-            <a:pPr algn="r" indent="0" marL="0">
+            <a:pPr marL="0" indent="0" algn="r">
               <a:buNone/>
             </a:pPr>
             <a:r>
@@ -6223,7 +5958,7 @@
         </p:nvSpPr>
         <p:spPr>
           <a:xfrm>
-            <a:off x="9992957" y="2871936"/>
+            <a:off x="9949827" y="2811553"/>
             <a:ext cx="853514" cy="123825"/>
           </a:xfrm>
           <a:prstGeom prst="rect">
@@ -6236,7 +5971,7 @@
           <a:bodyPr wrap="square" lIns="0" tIns="114300" rIns="114300" bIns="0" rtlCol="0" anchor="ctr"/>
           <a:lstStyle/>
           <a:p>
-            <a:pPr algn="r" indent="0" marL="0">
+            <a:pPr marL="0" indent="0" algn="r">
               <a:buNone/>
             </a:pPr>
             <a:r>
@@ -6262,7 +5997,7 @@
         </p:nvSpPr>
         <p:spPr>
           <a:xfrm>
-            <a:off x="9992957" y="3231059"/>
+            <a:off x="9949827" y="3170676"/>
             <a:ext cx="853514" cy="123825"/>
           </a:xfrm>
           <a:prstGeom prst="rect">
@@ -6275,7 +6010,7 @@
           <a:bodyPr wrap="square" lIns="0" tIns="114300" rIns="114300" bIns="0" rtlCol="0" anchor="ctr"/>
           <a:lstStyle/>
           <a:p>
-            <a:pPr algn="r" indent="0" marL="0">
+            <a:pPr marL="0" indent="0" algn="r">
               <a:buNone/>
             </a:pPr>
             <a:r>
@@ -6301,7 +6036,7 @@
         </p:nvSpPr>
         <p:spPr>
           <a:xfrm>
-            <a:off x="9992957" y="3537942"/>
+            <a:off x="9949827" y="3477559"/>
             <a:ext cx="853514" cy="123825"/>
           </a:xfrm>
           <a:prstGeom prst="rect">
@@ -6314,7 +6049,7 @@
           <a:bodyPr wrap="square" lIns="0" tIns="114300" rIns="114300" bIns="0" rtlCol="0" anchor="ctr"/>
           <a:lstStyle/>
           <a:p>
-            <a:pPr algn="r" indent="0" marL="0">
+            <a:pPr marL="0" indent="0" algn="r">
               <a:buNone/>
             </a:pPr>
             <a:r>
@@ -6353,7 +6088,7 @@
           <a:bodyPr wrap="square" lIns="0" tIns="114300" rIns="114300" bIns="0" rtlCol="0" anchor="ctr"/>
           <a:lstStyle/>
           <a:p>
-            <a:pPr algn="l" indent="0" marL="0">
+            <a:pPr marL="0" indent="0" algn="l">
               <a:buNone/>
             </a:pPr>
             <a:r>
@@ -6392,7 +6127,7 @@
           <a:bodyPr wrap="square" lIns="0" tIns="0" rIns="0" bIns="0" rtlCol="0" anchor="t"/>
           <a:lstStyle/>
           <a:p>
-            <a:pPr algn="l" indent="0" marL="0">
+            <a:pPr marL="0" indent="0" algn="l">
               <a:buNone/>
             </a:pPr>
             <a:r>
@@ -6418,7 +6153,7 @@
         </p:nvSpPr>
         <p:spPr>
           <a:xfrm>
-            <a:off x="4841240" y="2276177"/>
+            <a:off x="4789484" y="2215795"/>
             <a:ext cx="1073637" cy="123825"/>
           </a:xfrm>
           <a:prstGeom prst="rect">
@@ -6431,7 +6166,7 @@
           <a:bodyPr wrap="square" lIns="0" tIns="114300" rIns="114300" bIns="0" rtlCol="0" anchor="ctr"/>
           <a:lstStyle/>
           <a:p>
-            <a:pPr algn="r" indent="0" marL="0">
+            <a:pPr marL="0" indent="0" algn="r">
               <a:buNone/>
             </a:pPr>
             <a:r>
@@ -6457,7 +6192,7 @@
         </p:nvSpPr>
         <p:spPr>
           <a:xfrm>
-            <a:off x="4841240" y="2523827"/>
+            <a:off x="4789484" y="2463445"/>
             <a:ext cx="1073637" cy="123825"/>
           </a:xfrm>
           <a:prstGeom prst="rect">
@@ -6470,7 +6205,7 @@
           <a:bodyPr wrap="square" lIns="0" tIns="114300" rIns="114300" bIns="0" rtlCol="0" anchor="ctr"/>
           <a:lstStyle/>
           <a:p>
-            <a:pPr algn="r" indent="0" marL="0">
+            <a:pPr marL="0" indent="0" algn="r">
               <a:buNone/>
             </a:pPr>
             <a:r>
@@ -6496,7 +6231,7 @@
         </p:nvSpPr>
         <p:spPr>
           <a:xfrm>
-            <a:off x="4841240" y="2771477"/>
+            <a:off x="4789484" y="2711095"/>
             <a:ext cx="1073637" cy="123825"/>
           </a:xfrm>
           <a:prstGeom prst="rect">
@@ -6509,7 +6244,7 @@
           <a:bodyPr wrap="square" lIns="0" tIns="114300" rIns="114300" bIns="0" rtlCol="0" anchor="ctr"/>
           <a:lstStyle/>
           <a:p>
-            <a:pPr algn="r" indent="0" marL="0">
+            <a:pPr marL="0" indent="0" algn="r">
               <a:buNone/>
             </a:pPr>
             <a:r>
@@ -6535,7 +6270,7 @@
         </p:nvSpPr>
         <p:spPr>
           <a:xfrm>
-            <a:off x="4841240" y="3019127"/>
+            <a:off x="4789484" y="2958745"/>
             <a:ext cx="1073637" cy="123825"/>
           </a:xfrm>
           <a:prstGeom prst="rect">
@@ -6548,7 +6283,7 @@
           <a:bodyPr wrap="square" lIns="0" tIns="114300" rIns="114300" bIns="0" rtlCol="0" anchor="ctr"/>
           <a:lstStyle/>
           <a:p>
-            <a:pPr algn="r" indent="0" marL="0">
+            <a:pPr marL="0" indent="0" algn="r">
               <a:buNone/>
             </a:pPr>
             <a:r>
@@ -6574,7 +6309,7 @@
         </p:nvSpPr>
         <p:spPr>
           <a:xfrm>
-            <a:off x="4841240" y="3266777"/>
+            <a:off x="4789484" y="3206395"/>
             <a:ext cx="1073637" cy="123825"/>
           </a:xfrm>
           <a:prstGeom prst="rect">
@@ -6587,7 +6322,7 @@
           <a:bodyPr wrap="square" lIns="0" tIns="114300" rIns="114300" bIns="0" rtlCol="0" anchor="ctr"/>
           <a:lstStyle/>
           <a:p>
-            <a:pPr algn="r" indent="0" marL="0">
+            <a:pPr marL="0" indent="0" algn="r">
               <a:buNone/>
             </a:pPr>
             <a:r>
@@ -6613,7 +6348,7 @@
         </p:nvSpPr>
         <p:spPr>
           <a:xfrm>
-            <a:off x="4841240" y="3514427"/>
+            <a:off x="4789484" y="3454045"/>
             <a:ext cx="1073637" cy="123825"/>
           </a:xfrm>
           <a:prstGeom prst="rect">
@@ -6626,7 +6361,7 @@
           <a:bodyPr wrap="square" lIns="0" tIns="114300" rIns="114300" bIns="0" rtlCol="0" anchor="ctr"/>
           <a:lstStyle/>
           <a:p>
-            <a:pPr algn="r" indent="0" marL="0">
+            <a:pPr marL="0" indent="0" algn="r">
               <a:buNone/>
             </a:pPr>
             <a:r>
@@ -6652,7 +6387,7 @@
         </p:nvSpPr>
         <p:spPr>
           <a:xfrm>
-            <a:off x="4841240" y="3762077"/>
+            <a:off x="4789484" y="3701695"/>
             <a:ext cx="1073637" cy="123825"/>
           </a:xfrm>
           <a:prstGeom prst="rect">
@@ -6665,7 +6400,7 @@
           <a:bodyPr wrap="square" lIns="0" tIns="114300" rIns="114300" bIns="0" rtlCol="0" anchor="ctr"/>
           <a:lstStyle/>
           <a:p>
-            <a:pPr algn="r" indent="0" marL="0">
+            <a:pPr marL="0" indent="0" algn="r">
               <a:buNone/>
             </a:pPr>
             <a:r>
@@ -6691,7 +6426,7 @@
         </p:nvSpPr>
         <p:spPr>
           <a:xfrm>
-            <a:off x="4841240" y="4009727"/>
+            <a:off x="4789484" y="3949345"/>
             <a:ext cx="1073637" cy="123825"/>
           </a:xfrm>
           <a:prstGeom prst="rect">
@@ -6704,7 +6439,7 @@
           <a:bodyPr wrap="square" lIns="0" tIns="114300" rIns="114300" bIns="0" rtlCol="0" anchor="ctr"/>
           <a:lstStyle/>
           <a:p>
-            <a:pPr algn="r" indent="0" marL="0">
+            <a:pPr marL="0" indent="0" algn="r">
               <a:buNone/>
             </a:pPr>
             <a:r>
@@ -6730,7 +6465,7 @@
         </p:nvSpPr>
         <p:spPr>
           <a:xfrm>
-            <a:off x="4841240" y="4309765"/>
+            <a:off x="4789484" y="4249383"/>
             <a:ext cx="1073637" cy="123825"/>
           </a:xfrm>
           <a:prstGeom prst="rect">
@@ -6743,7 +6478,7 @@
           <a:bodyPr wrap="square" lIns="0" tIns="114300" rIns="114300" bIns="0" rtlCol="0" anchor="ctr"/>
           <a:lstStyle/>
           <a:p>
-            <a:pPr algn="r" indent="0" marL="0">
+            <a:pPr marL="0" indent="0" algn="r">
               <a:buNone/>
             </a:pPr>
             <a:r>
@@ -6769,7 +6504,7 @@
         </p:nvSpPr>
         <p:spPr>
           <a:xfrm>
-            <a:off x="9992957" y="2512665"/>
+            <a:off x="9949827" y="2452282"/>
             <a:ext cx="853514" cy="123825"/>
           </a:xfrm>
           <a:prstGeom prst="rect">
@@ -6782,7 +6517,7 @@
           <a:bodyPr wrap="square" lIns="0" tIns="114300" rIns="114300" bIns="0" rtlCol="0" anchor="ctr"/>
           <a:lstStyle/>
           <a:p>
-            <a:pPr algn="r" indent="0" marL="0">
+            <a:pPr marL="0" indent="0" algn="r">
               <a:buNone/>
             </a:pPr>
             <a:r>
@@ -6821,7 +6556,7 @@
           <a:bodyPr wrap="square" lIns="0" tIns="114300" rIns="114300" bIns="0" rtlCol="0" anchor="ctr"/>
           <a:lstStyle/>
           <a:p>
-            <a:pPr algn="l" indent="0" marL="0">
+            <a:pPr marL="0" indent="0" algn="l">
               <a:buNone/>
             </a:pPr>
             <a:r>
@@ -6860,7 +6595,7 @@
           <a:bodyPr wrap="square" lIns="0" tIns="114300" rIns="114300" bIns="0" rtlCol="0" anchor="ctr"/>
           <a:lstStyle/>
           <a:p>
-            <a:pPr algn="l" indent="0" marL="0">
+            <a:pPr marL="0" indent="0" algn="l">
               <a:buNone/>
             </a:pPr>
             <a:r>
@@ -6886,7 +6621,7 @@
         </p:nvSpPr>
         <p:spPr>
           <a:xfrm>
-            <a:off x="704832" y="2038052"/>
+            <a:off x="722084" y="1994922"/>
             <a:ext cx="858572" cy="133350"/>
           </a:xfrm>
           <a:prstGeom prst="rect">
@@ -6899,7 +6634,7 @@
           <a:bodyPr wrap="square" lIns="0" tIns="114300" rIns="114300" bIns="0" rtlCol="0" anchor="ctr"/>
           <a:lstStyle/>
           <a:p>
-            <a:pPr algn="l" indent="0" marL="0">
+            <a:pPr marL="0" indent="0" algn="l">
               <a:buNone/>
             </a:pPr>
             <a:r>
@@ -6938,7 +6673,7 @@
           <a:bodyPr wrap="square" lIns="0" tIns="114300" rIns="114300" bIns="0" rtlCol="0" anchor="ctr"/>
           <a:lstStyle/>
           <a:p>
-            <a:pPr algn="l" indent="0" marL="0">
+            <a:pPr marL="0" indent="0" algn="l">
               <a:buNone/>
             </a:pPr>
             <a:r>
@@ -6977,7 +6712,7 @@
           <a:bodyPr wrap="square" lIns="0" tIns="114300" rIns="114300" bIns="0" rtlCol="0" anchor="ctr"/>
           <a:lstStyle/>
           <a:p>
-            <a:pPr algn="r" indent="0" marL="0">
+            <a:pPr marL="0" indent="0" algn="r">
               <a:buNone/>
             </a:pPr>
             <a:r>
@@ -7016,7 +6751,7 @@
           <a:bodyPr wrap="square" lIns="0" tIns="114300" rIns="114300" bIns="0" rtlCol="0" anchor="ctr"/>
           <a:lstStyle/>
           <a:p>
-            <a:pPr algn="l" indent="0" marL="0">
+            <a:pPr marL="0" indent="0" algn="l">
               <a:buNone/>
             </a:pPr>
             <a:r>
@@ -7055,7 +6790,7 @@
           <a:bodyPr wrap="square" lIns="0" tIns="114300" rIns="114300" bIns="0" rtlCol="0" anchor="ctr"/>
           <a:lstStyle/>
           <a:p>
-            <a:pPr algn="r" indent="0" marL="0">
+            <a:pPr marL="0" indent="0" algn="r">
               <a:buNone/>
             </a:pPr>
             <a:r>
@@ -7094,7 +6829,7 @@
           <a:bodyPr wrap="square" lIns="0" tIns="114300" rIns="114300" bIns="0" rtlCol="0" anchor="ctr"/>
           <a:lstStyle/>
           <a:p>
-            <a:pPr algn="l" indent="0" marL="0">
+            <a:pPr marL="0" indent="0" algn="l">
               <a:buNone/>
             </a:pPr>
             <a:r>
@@ -7133,7 +6868,7 @@
           <a:bodyPr wrap="square" lIns="0" tIns="114300" rIns="114300" bIns="0" rtlCol="0" anchor="ctr"/>
           <a:lstStyle/>
           <a:p>
-            <a:pPr algn="r" indent="0" marL="0">
+            <a:pPr marL="0" indent="0" algn="r">
               <a:buNone/>
             </a:pPr>
             <a:r>
@@ -7172,7 +6907,7 @@
           <a:bodyPr wrap="square" lIns="0" tIns="114300" rIns="114300" bIns="0" rtlCol="0" anchor="ctr"/>
           <a:lstStyle/>
           <a:p>
-            <a:pPr algn="l" indent="0" marL="0">
+            <a:pPr marL="0" indent="0" algn="l">
               <a:buNone/>
             </a:pPr>
             <a:r>
@@ -7211,7 +6946,7 @@
           <a:bodyPr wrap="square" lIns="0" tIns="114300" rIns="114300" bIns="0" rtlCol="0" anchor="ctr"/>
           <a:lstStyle/>
           <a:p>
-            <a:pPr algn="r" indent="0" marL="0">
+            <a:pPr marL="0" indent="0" algn="r">
               <a:buNone/>
             </a:pPr>
             <a:r>
@@ -7250,7 +6985,7 @@
           <a:bodyPr wrap="square" lIns="0" tIns="114300" rIns="114300" bIns="0" rtlCol="0" anchor="ctr"/>
           <a:lstStyle/>
           <a:p>
-            <a:pPr algn="l" indent="0" marL="0">
+            <a:pPr marL="0" indent="0" algn="l">
               <a:buNone/>
             </a:pPr>
             <a:r>
@@ -7289,7 +7024,7 @@
           <a:bodyPr wrap="square" lIns="0" tIns="114300" rIns="114300" bIns="0" rtlCol="0" anchor="ctr"/>
           <a:lstStyle/>
           <a:p>
-            <a:pPr algn="l" indent="0" marL="0">
+            <a:pPr marL="0" indent="0" algn="l">
               <a:buNone/>
             </a:pPr>
             <a:r>
@@ -7328,7 +7063,7 @@
           <a:bodyPr wrap="square" lIns="0" tIns="114300" rIns="114300" bIns="0" rtlCol="0" anchor="ctr"/>
           <a:lstStyle/>
           <a:p>
-            <a:pPr algn="l" indent="0" marL="0">
+            <a:pPr marL="0" indent="0" algn="l">
               <a:buNone/>
             </a:pPr>
             <a:r>
@@ -7367,7 +7102,7 @@
           <a:bodyPr wrap="square" lIns="0" tIns="114300" rIns="114300" bIns="0" rtlCol="0" anchor="ctr"/>
           <a:lstStyle/>
           <a:p>
-            <a:pPr algn="l" indent="0" marL="0">
+            <a:pPr marL="0" indent="0" algn="l">
               <a:buNone/>
             </a:pPr>
             <a:r>
@@ -7406,7 +7141,7 @@
           <a:bodyPr wrap="square" lIns="0" tIns="114300" rIns="114300" bIns="0" rtlCol="0" anchor="ctr"/>
           <a:lstStyle/>
           <a:p>
-            <a:pPr algn="r" indent="0" marL="0">
+            <a:pPr marL="0" indent="0" algn="r">
               <a:buNone/>
             </a:pPr>
             <a:r>
@@ -7445,7 +7180,7 @@
           <a:bodyPr wrap="square" lIns="0" tIns="114300" rIns="114300" bIns="0" rtlCol="0" anchor="ctr"/>
           <a:lstStyle/>
           <a:p>
-            <a:pPr algn="r" indent="0" marL="0">
+            <a:pPr marL="0" indent="0" algn="r">
               <a:buNone/>
             </a:pPr>
             <a:r>
@@ -7484,7 +7219,7 @@
           <a:bodyPr wrap="square" lIns="0" tIns="114300" rIns="114300" bIns="0" rtlCol="0" anchor="ctr"/>
           <a:lstStyle/>
           <a:p>
-            <a:pPr algn="r" indent="0" marL="0">
+            <a:pPr marL="0" indent="0" algn="r">
               <a:buNone/>
             </a:pPr>
             <a:r>
@@ -7523,7 +7258,7 @@
           <a:bodyPr wrap="square" lIns="0" tIns="114300" rIns="114300" bIns="0" rtlCol="0" anchor="ctr"/>
           <a:lstStyle/>
           <a:p>
-            <a:pPr algn="r" indent="0" marL="0">
+            <a:pPr marL="0" indent="0" algn="r">
               <a:buNone/>
             </a:pPr>
             <a:r>
@@ -7562,7 +7297,7 @@
           <a:bodyPr wrap="square" lIns="0" tIns="114300" rIns="114300" bIns="0" rtlCol="0" anchor="ctr"/>
           <a:lstStyle/>
           <a:p>
-            <a:pPr algn="r" indent="0" marL="0">
+            <a:pPr marL="0" indent="0" algn="r">
               <a:buNone/>
             </a:pPr>
             <a:r>
@@ -7601,7 +7336,7 @@
           <a:bodyPr wrap="square" lIns="0" tIns="114300" rIns="114300" bIns="0" rtlCol="0" anchor="ctr"/>
           <a:lstStyle/>
           <a:p>
-            <a:pPr algn="r" indent="0" marL="0">
+            <a:pPr marL="0" indent="0" algn="r">
               <a:buNone/>
             </a:pPr>
             <a:r>
@@ -7640,7 +7375,7 @@
           <a:bodyPr wrap="square" lIns="0" tIns="114300" rIns="114300" bIns="0" rtlCol="0" anchor="ctr"/>
           <a:lstStyle/>
           <a:p>
-            <a:pPr algn="r" indent="0" marL="0">
+            <a:pPr marL="0" indent="0" algn="r">
               <a:buNone/>
             </a:pPr>
             <a:r>
@@ -7679,7 +7414,7 @@
           <a:bodyPr wrap="square" lIns="0" tIns="0" rIns="0" bIns="0" rtlCol="0" anchor="t"/>
           <a:lstStyle/>
           <a:p>
-            <a:pPr algn="l" indent="0" marL="0">
+            <a:pPr marL="0" indent="0" algn="l">
               <a:buNone/>
             </a:pPr>
             <a:r>
@@ -7718,7 +7453,7 @@
           <a:bodyPr wrap="square" lIns="0" tIns="114300" rIns="114300" bIns="0" rtlCol="0" anchor="ctr"/>
           <a:lstStyle/>
           <a:p>
-            <a:pPr algn="r" indent="0" marL="0">
+            <a:pPr marL="0" indent="0" algn="r">
               <a:buNone/>
             </a:pPr>
             <a:r>
@@ -7757,7 +7492,7 @@
           <a:bodyPr wrap="square" lIns="0" tIns="114300" rIns="114300" bIns="0" rtlCol="0" anchor="ctr"/>
           <a:lstStyle/>
           <a:p>
-            <a:pPr algn="r" indent="0" marL="0">
+            <a:pPr marL="0" indent="0" algn="r">
               <a:buNone/>
             </a:pPr>
             <a:r>
@@ -7796,7 +7531,7 @@
           <a:bodyPr wrap="square" lIns="0" tIns="114300" rIns="114300" bIns="0" rtlCol="0" anchor="ctr"/>
           <a:lstStyle/>
           <a:p>
-            <a:pPr algn="r" indent="0" marL="0">
+            <a:pPr marL="0" indent="0" algn="r">
               <a:buNone/>
             </a:pPr>
             <a:r>
@@ -7835,7 +7570,7 @@
           <a:bodyPr wrap="square" lIns="0" tIns="114300" rIns="114300" bIns="0" rtlCol="0" anchor="ctr"/>
           <a:lstStyle/>
           <a:p>
-            <a:pPr algn="r" indent="0" marL="0">
+            <a:pPr marL="0" indent="0" algn="r">
               <a:buNone/>
             </a:pPr>
             <a:r>
@@ -7874,7 +7609,7 @@
           <a:bodyPr wrap="square" lIns="0" tIns="114300" rIns="114300" bIns="0" rtlCol="0" anchor="ctr"/>
           <a:lstStyle/>
           <a:p>
-            <a:pPr algn="r" indent="0" marL="0">
+            <a:pPr marL="0" indent="0" algn="r">
               <a:buNone/>
             </a:pPr>
             <a:r>
@@ -7913,7 +7648,7 @@
           <a:bodyPr wrap="square" lIns="0" tIns="114300" rIns="114300" bIns="0" rtlCol="0" anchor="ctr"/>
           <a:lstStyle/>
           <a:p>
-            <a:pPr algn="r" indent="0" marL="0">
+            <a:pPr marL="0" indent="0" algn="r">
               <a:buNone/>
             </a:pPr>
             <a:r>
@@ -7952,7 +7687,7 @@
           <a:bodyPr wrap="square" lIns="0" tIns="114300" rIns="114300" bIns="0" rtlCol="0" anchor="ctr"/>
           <a:lstStyle/>
           <a:p>
-            <a:pPr algn="r" indent="0" marL="0">
+            <a:pPr marL="0" indent="0" algn="r">
               <a:buNone/>
             </a:pPr>
             <a:r>
@@ -7991,7 +7726,7 @@
           <a:bodyPr wrap="square" lIns="0" tIns="114300" rIns="114300" bIns="0" rtlCol="0" anchor="ctr"/>
           <a:lstStyle/>
           <a:p>
-            <a:pPr algn="r" indent="0" marL="0">
+            <a:pPr marL="0" indent="0" algn="r">
               <a:buNone/>
             </a:pPr>
             <a:r>
@@ -8030,7 +7765,7 @@
           <a:bodyPr wrap="square" lIns="0" tIns="114300" rIns="114300" bIns="0" rtlCol="0" anchor="ctr"/>
           <a:lstStyle/>
           <a:p>
-            <a:pPr algn="r" indent="0" marL="0">
+            <a:pPr marL="0" indent="0" algn="r">
               <a:buNone/>
             </a:pPr>
             <a:r>
@@ -8069,7 +7804,7 @@
           <a:bodyPr wrap="square" lIns="0" tIns="114300" rIns="114300" bIns="0" rtlCol="0" anchor="ctr"/>
           <a:lstStyle/>
           <a:p>
-            <a:pPr algn="r" indent="0" marL="0">
+            <a:pPr marL="0" indent="0" algn="r">
               <a:buNone/>
             </a:pPr>
             <a:r>
@@ -8108,7 +7843,7 @@
           <a:bodyPr wrap="square" lIns="0" tIns="114300" rIns="114300" bIns="0" rtlCol="0" anchor="ctr"/>
           <a:lstStyle/>
           <a:p>
-            <a:pPr algn="r" indent="0" marL="0">
+            <a:pPr marL="0" indent="0" algn="r">
               <a:buNone/>
             </a:pPr>
             <a:r>
@@ -8147,7 +7882,7 @@
           <a:bodyPr wrap="square" lIns="0" tIns="114300" rIns="114300" bIns="0" rtlCol="0" anchor="ctr"/>
           <a:lstStyle/>
           <a:p>
-            <a:pPr algn="r" indent="0" marL="0">
+            <a:pPr marL="0" indent="0" algn="r">
               <a:buNone/>
             </a:pPr>
             <a:r>
@@ -8186,7 +7921,7 @@
           <a:bodyPr wrap="square" lIns="0" tIns="114300" rIns="114300" bIns="0" rtlCol="0" anchor="ctr"/>
           <a:lstStyle/>
           <a:p>
-            <a:pPr algn="r" indent="0" marL="0">
+            <a:pPr marL="0" indent="0" algn="r">
               <a:buNone/>
             </a:pPr>
             <a:r>
@@ -8225,7 +7960,7 @@
           <a:bodyPr wrap="square" lIns="0" tIns="114300" rIns="114300" bIns="0" rtlCol="0" anchor="ctr"/>
           <a:lstStyle/>
           <a:p>
-            <a:pPr algn="r" indent="0" marL="0">
+            <a:pPr marL="0" indent="0" algn="r">
               <a:buNone/>
             </a:pPr>
             <a:r>
@@ -8264,7 +7999,7 @@
           <a:bodyPr wrap="square" lIns="0" tIns="114300" rIns="114300" bIns="0" rtlCol="0" anchor="ctr"/>
           <a:lstStyle/>
           <a:p>
-            <a:pPr algn="r" indent="0" marL="0">
+            <a:pPr marL="0" indent="0" algn="r">
               <a:buNone/>
             </a:pPr>
             <a:r>
@@ -8303,7 +8038,7 @@
           <a:bodyPr wrap="square" lIns="0" tIns="114300" rIns="114300" bIns="0" rtlCol="0" anchor="ctr"/>
           <a:lstStyle/>
           <a:p>
-            <a:pPr algn="r" indent="0" marL="0">
+            <a:pPr marL="0" indent="0" algn="r">
               <a:buNone/>
             </a:pPr>
             <a:r>
@@ -8342,7 +8077,7 @@
           <a:bodyPr wrap="square" lIns="0" tIns="114300" rIns="114300" bIns="0" rtlCol="0" anchor="ctr"/>
           <a:lstStyle/>
           <a:p>
-            <a:pPr algn="r" indent="0" marL="0">
+            <a:pPr marL="0" indent="0" algn="r">
               <a:buNone/>
             </a:pPr>
             <a:r>
@@ -8381,7 +8116,7 @@
           <a:bodyPr wrap="square" lIns="0" tIns="114300" rIns="114300" bIns="0" rtlCol="0" anchor="ctr"/>
           <a:lstStyle/>
           <a:p>
-            <a:pPr algn="r" indent="0" marL="0">
+            <a:pPr marL="0" indent="0" algn="r">
               <a:buNone/>
             </a:pPr>
             <a:r>
@@ -8420,7 +8155,7 @@
           <a:bodyPr wrap="square" lIns="0" tIns="114300" rIns="114300" bIns="0" rtlCol="0" anchor="ctr"/>
           <a:lstStyle/>
           <a:p>
-            <a:pPr algn="r" indent="0" marL="0">
+            <a:pPr marL="0" indent="0" algn="r">
               <a:buNone/>
             </a:pPr>
             <a:r>
@@ -8459,7 +8194,7 @@
           <a:bodyPr wrap="square" lIns="0" tIns="114300" rIns="114300" bIns="0" rtlCol="0" anchor="ctr"/>
           <a:lstStyle/>
           <a:p>
-            <a:pPr algn="r" indent="0" marL="0">
+            <a:pPr marL="0" indent="0" algn="r">
               <a:buNone/>
             </a:pPr>
             <a:r>
@@ -8498,7 +8233,7 @@
           <a:bodyPr wrap="square" lIns="0" tIns="114300" rIns="114300" bIns="0" rtlCol="0" anchor="ctr"/>
           <a:lstStyle/>
           <a:p>
-            <a:pPr algn="r" indent="0" marL="0">
+            <a:pPr marL="0" indent="0" algn="r">
               <a:buNone/>
             </a:pPr>
             <a:r>
@@ -8537,7 +8272,7 @@
           <a:bodyPr wrap="square" lIns="0" tIns="114300" rIns="114300" bIns="0" rtlCol="0" anchor="ctr"/>
           <a:lstStyle/>
           <a:p>
-            <a:pPr algn="r" indent="0" marL="0">
+            <a:pPr marL="0" indent="0" algn="r">
               <a:buNone/>
             </a:pPr>
             <a:r>
@@ -8576,7 +8311,7 @@
           <a:bodyPr wrap="square" lIns="0" tIns="114300" rIns="114300" bIns="0" rtlCol="0" anchor="ctr"/>
           <a:lstStyle/>
           <a:p>
-            <a:pPr algn="r" indent="0" marL="0">
+            <a:pPr marL="0" indent="0" algn="r">
               <a:buNone/>
             </a:pPr>
             <a:r>
@@ -8615,7 +8350,7 @@
           <a:bodyPr wrap="square" lIns="0" tIns="114300" rIns="114300" bIns="0" rtlCol="0" anchor="ctr"/>
           <a:lstStyle/>
           <a:p>
-            <a:pPr algn="r" indent="0" marL="0">
+            <a:pPr marL="0" indent="0" algn="r">
               <a:buNone/>
             </a:pPr>
             <a:r>
@@ -8654,7 +8389,7 @@
           <a:bodyPr wrap="square" lIns="0" tIns="114300" rIns="114300" bIns="0" rtlCol="0" anchor="ctr"/>
           <a:lstStyle/>
           <a:p>
-            <a:pPr algn="r" indent="0" marL="0">
+            <a:pPr marL="0" indent="0" algn="r">
               <a:buNone/>
             </a:pPr>
             <a:r>
@@ -8693,7 +8428,7 @@
           <a:bodyPr wrap="square" lIns="0" tIns="114300" rIns="114300" bIns="0" rtlCol="0" anchor="ctr"/>
           <a:lstStyle/>
           <a:p>
-            <a:pPr algn="r" indent="0" marL="0">
+            <a:pPr marL="0" indent="0" algn="r">
               <a:buNone/>
             </a:pPr>
             <a:r>
@@ -8732,7 +8467,7 @@
           <a:bodyPr wrap="square" lIns="0" tIns="114300" rIns="114300" bIns="0" rtlCol="0" anchor="ctr"/>
           <a:lstStyle/>
           <a:p>
-            <a:pPr algn="r" indent="0" marL="0">
+            <a:pPr marL="0" indent="0" algn="r">
               <a:buNone/>
             </a:pPr>
             <a:r>
@@ -8771,7 +8506,7 @@
           <a:bodyPr wrap="square" lIns="0" tIns="114300" rIns="114300" bIns="0" rtlCol="0" anchor="ctr"/>
           <a:lstStyle/>
           <a:p>
-            <a:pPr algn="r" indent="0" marL="0">
+            <a:pPr marL="0" indent="0" algn="r">
               <a:buNone/>
             </a:pPr>
             <a:r>
@@ -8810,7 +8545,7 @@
           <a:bodyPr wrap="square" lIns="0" tIns="114300" rIns="114300" bIns="0" rtlCol="0" anchor="ctr"/>
           <a:lstStyle/>
           <a:p>
-            <a:pPr algn="r" indent="0" marL="0">
+            <a:pPr marL="0" indent="0" algn="r">
               <a:buNone/>
             </a:pPr>
             <a:r>
@@ -8849,7 +8584,7 @@
           <a:bodyPr wrap="square" lIns="0" tIns="114300" rIns="114300" bIns="0" rtlCol="0" anchor="ctr"/>
           <a:lstStyle/>
           <a:p>
-            <a:pPr algn="r" indent="0" marL="0">
+            <a:pPr marL="0" indent="0" algn="r">
               <a:buNone/>
             </a:pPr>
             <a:r>
@@ -8888,7 +8623,7 @@
           <a:bodyPr wrap="square" lIns="0" tIns="114300" rIns="114300" bIns="0" rtlCol="0" anchor="ctr"/>
           <a:lstStyle/>
           <a:p>
-            <a:pPr algn="r" indent="0" marL="0">
+            <a:pPr marL="0" indent="0" algn="r">
               <a:buNone/>
             </a:pPr>
             <a:r>
@@ -8927,7 +8662,7 @@
           <a:bodyPr wrap="square" lIns="0" tIns="114300" rIns="114300" bIns="0" rtlCol="0" anchor="ctr"/>
           <a:lstStyle/>
           <a:p>
-            <a:pPr algn="r" indent="0" marL="0">
+            <a:pPr marL="0" indent="0" algn="r">
               <a:buNone/>
             </a:pPr>
             <a:r>
@@ -8966,7 +8701,7 @@
           <a:bodyPr wrap="square" lIns="0" tIns="114300" rIns="114300" bIns="0" rtlCol="0" anchor="ctr"/>
           <a:lstStyle/>
           <a:p>
-            <a:pPr algn="r" indent="0" marL="0">
+            <a:pPr marL="0" indent="0" algn="r">
               <a:buNone/>
             </a:pPr>
             <a:r>
@@ -9005,7 +8740,7 @@
           <a:bodyPr wrap="square" lIns="0" tIns="114300" rIns="114300" bIns="0" rtlCol="0" anchor="ctr"/>
           <a:lstStyle/>
           <a:p>
-            <a:pPr algn="r" indent="0" marL="0">
+            <a:pPr marL="0" indent="0" algn="r">
               <a:buNone/>
             </a:pPr>
             <a:r>
@@ -9044,7 +8779,7 @@
           <a:bodyPr wrap="square" lIns="0" tIns="114300" rIns="114300" bIns="0" rtlCol="0" anchor="ctr"/>
           <a:lstStyle/>
           <a:p>
-            <a:pPr algn="r" indent="0" marL="0">
+            <a:pPr marL="0" indent="0" algn="r">
               <a:buNone/>
             </a:pPr>
             <a:r>
@@ -9083,7 +8818,7 @@
           <a:bodyPr wrap="square" lIns="0" tIns="114300" rIns="114300" bIns="0" rtlCol="0" anchor="ctr"/>
           <a:lstStyle/>
           <a:p>
-            <a:pPr algn="r" indent="0" marL="0">
+            <a:pPr marL="0" indent="0" algn="r">
               <a:buNone/>
             </a:pPr>
             <a:r>
@@ -9122,7 +8857,7 @@
           <a:bodyPr wrap="square" lIns="0" tIns="114300" rIns="114300" bIns="0" rtlCol="0" anchor="ctr"/>
           <a:lstStyle/>
           <a:p>
-            <a:pPr algn="r" indent="0" marL="0">
+            <a:pPr marL="0" indent="0" algn="r">
               <a:buNone/>
             </a:pPr>
             <a:r>
@@ -9161,7 +8896,7 @@
           <a:bodyPr wrap="square" lIns="0" tIns="0" rIns="0" bIns="0" rtlCol="0" anchor="t"/>
           <a:lstStyle/>
           <a:p>
-            <a:pPr algn="l" indent="0" marL="0">
+            <a:pPr marL="0" indent="0" algn="l">
               <a:buNone/>
             </a:pPr>
             <a:r>
@@ -9200,7 +8935,7 @@
           <a:bodyPr wrap="square" lIns="0" tIns="0" rIns="0" bIns="0" rtlCol="0" anchor="t"/>
           <a:lstStyle/>
           <a:p>
-            <a:pPr algn="l" indent="0" marL="0">
+            <a:pPr marL="0" indent="0" algn="l">
               <a:buNone/>
             </a:pPr>
             <a:r>
@@ -9239,7 +8974,7 @@
           <a:bodyPr wrap="square" lIns="0" tIns="0" rIns="0" bIns="0" rtlCol="0" anchor="t"/>
           <a:lstStyle/>
           <a:p>
-            <a:pPr algn="ctr" indent="0" marL="0">
+            <a:pPr marL="0" indent="0" algn="ctr">
               <a:buNone/>
             </a:pPr>
             <a:r>
@@ -9278,7 +9013,7 @@
           <a:bodyPr wrap="square" lIns="0" tIns="0" rIns="0" bIns="0" rtlCol="0" anchor="t"/>
           <a:lstStyle/>
           <a:p>
-            <a:pPr algn="ctr" indent="0" marL="0">
+            <a:pPr marL="0" indent="0" algn="ctr">
               <a:buNone/>
             </a:pPr>
             <a:r>
@@ -9317,7 +9052,7 @@
           <a:bodyPr wrap="square" lIns="0" tIns="0" rIns="0" bIns="0" rtlCol="0" anchor="t"/>
           <a:lstStyle/>
           <a:p>
-            <a:pPr algn="ctr" indent="0" marL="0">
+            <a:pPr marL="0" indent="0" algn="ctr">
               <a:buNone/>
             </a:pPr>
             <a:r>
@@ -9356,7 +9091,7 @@
           <a:bodyPr wrap="square" lIns="0" tIns="114300" rIns="114300" bIns="0" rtlCol="0" anchor="ctr"/>
           <a:lstStyle/>
           <a:p>
-            <a:pPr algn="r" indent="0" marL="0">
+            <a:pPr marL="0" indent="0" algn="r">
               <a:buNone/>
             </a:pPr>
             <a:r>
@@ -9395,7 +9130,7 @@
           <a:bodyPr wrap="square" lIns="0" tIns="114300" rIns="114300" bIns="0" rtlCol="0" anchor="ctr"/>
           <a:lstStyle/>
           <a:p>
-            <a:pPr algn="r" indent="0" marL="0">
+            <a:pPr marL="0" indent="0" algn="r">
               <a:buNone/>
             </a:pPr>
             <a:r>
@@ -9434,7 +9169,7 @@
           <a:bodyPr wrap="square" lIns="0" tIns="114300" rIns="114300" bIns="0" rtlCol="0" anchor="ctr"/>
           <a:lstStyle/>
           <a:p>
-            <a:pPr algn="r" indent="0" marL="0">
+            <a:pPr marL="0" indent="0" algn="r">
               <a:buNone/>
             </a:pPr>
             <a:r>
@@ -9473,7 +9208,7 @@
           <a:bodyPr wrap="square" lIns="0" tIns="114300" rIns="114300" bIns="0" rtlCol="0" anchor="ctr"/>
           <a:lstStyle/>
           <a:p>
-            <a:pPr algn="r" indent="0" marL="0">
+            <a:pPr marL="0" indent="0" algn="r">
               <a:buNone/>
             </a:pPr>
             <a:r>
@@ -9512,7 +9247,7 @@
           <a:bodyPr wrap="square" lIns="0" tIns="114300" rIns="114300" bIns="0" rtlCol="0" anchor="ctr"/>
           <a:lstStyle/>
           <a:p>
-            <a:pPr algn="r" indent="0" marL="0">
+            <a:pPr marL="0" indent="0" algn="r">
               <a:buNone/>
             </a:pPr>
             <a:r>
@@ -9551,7 +9286,7 @@
           <a:bodyPr wrap="square" lIns="0" tIns="114300" rIns="114300" bIns="0" rtlCol="0" anchor="ctr"/>
           <a:lstStyle/>
           <a:p>
-            <a:pPr algn="r" indent="0" marL="0">
+            <a:pPr marL="0" indent="0" algn="r">
               <a:buNone/>
             </a:pPr>
             <a:r>
@@ -9590,7 +9325,7 @@
           <a:bodyPr wrap="square" lIns="0" tIns="0" rIns="0" bIns="0" rtlCol="0" anchor="t"/>
           <a:lstStyle/>
           <a:p>
-            <a:pPr algn="ctr" indent="0" marL="0">
+            <a:pPr marL="0" indent="0" algn="ctr">
               <a:buNone/>
             </a:pPr>
             <a:r>
@@ -9629,7 +9364,7 @@
           <a:bodyPr wrap="square" lIns="0" tIns="0" rIns="0" bIns="0" rtlCol="0" anchor="t"/>
           <a:lstStyle/>
           <a:p>
-            <a:pPr algn="ctr" indent="0" marL="0">
+            <a:pPr marL="0" indent="0" algn="ctr">
               <a:buNone/>
             </a:pPr>
             <a:r>
@@ -9674,14 +9409,14 @@
       </p:grpSpPr>
       <p:pic>
         <p:nvPicPr>
-          <p:cNvPr id="2" name="Image 0" descr="C:\01_Repositorios\02_CRM\02_Informe_Semetral\dash\retail\ppt_slides\sk_02_main.png">    </p:cNvPr>
+          <p:cNvPr id="2" name="Image 0" descr="C:\01_Repositorios\02_CRM\02_Informe_Semetral\dash\retail\ppt_slides\sk_02_main.png"/>
           <p:cNvPicPr>
             <a:picLocks noChangeAspect="1"/>
           </p:cNvPicPr>
           <p:nvPr/>
         </p:nvPicPr>
         <p:blipFill>
-          <a:blip r:embed="rId1"/>
+          <a:blip r:embed="rId3"/>
           <a:stretch>
             <a:fillRect/>
           </a:stretch>
@@ -9717,7 +9452,7 @@
           <a:bodyPr wrap="square" lIns="0" tIns="0" rIns="0" bIns="0" rtlCol="0" anchor="t"/>
           <a:lstStyle/>
           <a:p>
-            <a:pPr algn="l" indent="0" marL="0">
+            <a:pPr marL="0" indent="0" algn="l">
               <a:buNone/>
             </a:pPr>
             <a:r>
@@ -9756,7 +9491,7 @@
           <a:bodyPr wrap="square" lIns="0" tIns="0" rIns="0" bIns="0" rtlCol="0" anchor="t"/>
           <a:lstStyle/>
           <a:p>
-            <a:pPr algn="l" indent="0" marL="0">
+            <a:pPr marL="0" indent="0" algn="l">
               <a:buNone/>
             </a:pPr>
             <a:r>
@@ -9795,7 +9530,7 @@
           <a:bodyPr wrap="square" lIns="0" tIns="0" rIns="0" bIns="0" rtlCol="0" anchor="t"/>
           <a:lstStyle/>
           <a:p>
-            <a:pPr algn="l" indent="0" marL="0">
+            <a:pPr marL="0" indent="0" algn="l">
               <a:buNone/>
             </a:pPr>
             <a:r>
@@ -9834,7 +9569,7 @@
           <a:bodyPr wrap="square" lIns="0" tIns="0" rIns="0" bIns="0" rtlCol="0" anchor="t"/>
           <a:lstStyle/>
           <a:p>
-            <a:pPr algn="l" indent="0" marL="0">
+            <a:pPr marL="0" indent="0" algn="l">
               <a:buNone/>
             </a:pPr>
             <a:r>
@@ -9873,7 +9608,7 @@
           <a:bodyPr wrap="square" lIns="0" tIns="0" rIns="0" bIns="0" rtlCol="0" anchor="t"/>
           <a:lstStyle/>
           <a:p>
-            <a:pPr algn="l" indent="0" marL="0">
+            <a:pPr marL="0" indent="0" algn="l">
               <a:buNone/>
             </a:pPr>
             <a:r>
@@ -9912,7 +9647,7 @@
           <a:bodyPr wrap="square" lIns="0" tIns="0" rIns="0" bIns="0" rtlCol="0" anchor="t"/>
           <a:lstStyle/>
           <a:p>
-            <a:pPr algn="l" indent="0" marL="0">
+            <a:pPr marL="0" indent="0" algn="l">
               <a:buNone/>
             </a:pPr>
             <a:r>
@@ -9951,7 +9686,7 @@
           <a:bodyPr wrap="square" lIns="0" tIns="0" rIns="0" bIns="0" rtlCol="0" anchor="t"/>
           <a:lstStyle/>
           <a:p>
-            <a:pPr algn="l" indent="0" marL="0">
+            <a:pPr marL="0" indent="0" algn="l">
               <a:buNone/>
             </a:pPr>
             <a:r>
@@ -9990,7 +9725,7 @@
           <a:bodyPr wrap="square" lIns="0" tIns="0" rIns="0" bIns="0" rtlCol="0" anchor="t"/>
           <a:lstStyle/>
           <a:p>
-            <a:pPr algn="l" indent="0" marL="0">
+            <a:pPr marL="0" indent="0" algn="l">
               <a:buNone/>
             </a:pPr>
             <a:r>
@@ -10029,7 +9764,7 @@
           <a:bodyPr wrap="square" lIns="0" tIns="0" rIns="0" bIns="0" rtlCol="0" anchor="t"/>
           <a:lstStyle/>
           <a:p>
-            <a:pPr algn="l" indent="0" marL="0">
+            <a:pPr marL="0" indent="0" algn="l">
               <a:buNone/>
             </a:pPr>
             <a:r>
@@ -10068,7 +9803,7 @@
           <a:bodyPr wrap="square" lIns="0" tIns="0" rIns="0" bIns="0" rtlCol="0" anchor="t"/>
           <a:lstStyle/>
           <a:p>
-            <a:pPr algn="l" indent="0" marL="0">
+            <a:pPr marL="0" indent="0" algn="l">
               <a:buNone/>
             </a:pPr>
             <a:r>
@@ -10107,7 +9842,7 @@
           <a:bodyPr wrap="square" lIns="0" tIns="0" rIns="0" bIns="0" rtlCol="0" anchor="t"/>
           <a:lstStyle/>
           <a:p>
-            <a:pPr algn="l" indent="0" marL="0">
+            <a:pPr marL="0" indent="0" algn="l">
               <a:buNone/>
             </a:pPr>
             <a:r>
@@ -10146,7 +9881,7 @@
           <a:bodyPr wrap="square" lIns="0" tIns="0" rIns="0" bIns="0" rtlCol="0" anchor="t"/>
           <a:lstStyle/>
           <a:p>
-            <a:pPr algn="l" indent="0" marL="0">
+            <a:pPr marL="0" indent="0" algn="l">
               <a:buNone/>
             </a:pPr>
             <a:r>
@@ -10185,7 +9920,7 @@
           <a:bodyPr wrap="square" lIns="0" tIns="0" rIns="0" bIns="0" rtlCol="0" anchor="t"/>
           <a:lstStyle/>
           <a:p>
-            <a:pPr algn="l" indent="0" marL="0">
+            <a:pPr marL="0" indent="0" algn="l">
               <a:buNone/>
             </a:pPr>
             <a:r>
@@ -10224,7 +9959,7 @@
           <a:bodyPr wrap="square" lIns="0" tIns="114300" rIns="114300" bIns="0" rtlCol="0" anchor="ctr"/>
           <a:lstStyle/>
           <a:p>
-            <a:pPr algn="l" indent="0" marL="0">
+            <a:pPr marL="0" indent="0" algn="l">
               <a:buNone/>
             </a:pPr>
             <a:r>
@@ -10263,7 +9998,7 @@
           <a:bodyPr wrap="square" lIns="0" tIns="114300" rIns="114300" bIns="0" rtlCol="0" anchor="ctr"/>
           <a:lstStyle/>
           <a:p>
-            <a:pPr algn="l" indent="0" marL="0">
+            <a:pPr marL="0" indent="0" algn="l">
               <a:buNone/>
             </a:pPr>
             <a:r>
@@ -10289,7 +10024,7 @@
         </p:nvSpPr>
         <p:spPr>
           <a:xfrm>
-            <a:off x="4183994" y="2044005"/>
+            <a:off x="4192620" y="2009501"/>
             <a:ext cx="931845" cy="133350"/>
           </a:xfrm>
           <a:prstGeom prst="rect">
@@ -10302,7 +10037,7 @@
           <a:bodyPr wrap="square" lIns="0" tIns="114300" rIns="114300" bIns="0" rtlCol="0" anchor="ctr"/>
           <a:lstStyle/>
           <a:p>
-            <a:pPr algn="r" indent="0" marL="0">
+            <a:pPr marL="0" indent="0" algn="r">
               <a:buNone/>
             </a:pPr>
             <a:r>
@@ -10328,7 +10063,7 @@
         </p:nvSpPr>
         <p:spPr>
           <a:xfrm>
-            <a:off x="9550689" y="2044005"/>
+            <a:off x="9585193" y="2018127"/>
             <a:ext cx="1041293" cy="133350"/>
           </a:xfrm>
           <a:prstGeom prst="rect">
@@ -10341,7 +10076,7 @@
           <a:bodyPr wrap="square" lIns="0" tIns="114300" rIns="114300" bIns="0" rtlCol="0" anchor="ctr"/>
           <a:lstStyle/>
           <a:p>
-            <a:pPr algn="r" indent="0" marL="0">
+            <a:pPr marL="0" indent="0" algn="r">
               <a:buNone/>
             </a:pPr>
             <a:r>
@@ -10367,7 +10102,7 @@
         </p:nvSpPr>
         <p:spPr>
           <a:xfrm>
-            <a:off x="1826574" y="2044005"/>
+            <a:off x="1835200" y="2009501"/>
             <a:ext cx="912837" cy="133350"/>
           </a:xfrm>
           <a:prstGeom prst="rect">
@@ -10380,7 +10115,7 @@
           <a:bodyPr wrap="square" lIns="0" tIns="114300" rIns="114300" bIns="0" rtlCol="0" anchor="ctr"/>
           <a:lstStyle/>
           <a:p>
-            <a:pPr algn="r" indent="0" marL="0">
+            <a:pPr marL="0" indent="0" algn="r">
               <a:buNone/>
             </a:pPr>
             <a:r>
@@ -10406,7 +10141,7 @@
         </p:nvSpPr>
         <p:spPr>
           <a:xfrm>
-            <a:off x="3262889" y="2044005"/>
+            <a:off x="3271515" y="2009501"/>
             <a:ext cx="948247" cy="133350"/>
           </a:xfrm>
           <a:prstGeom prst="rect">
@@ -10419,7 +10154,7 @@
           <a:bodyPr wrap="square" lIns="0" tIns="114300" rIns="114300" bIns="0" rtlCol="0" anchor="ctr"/>
           <a:lstStyle/>
           <a:p>
-            <a:pPr algn="r" indent="0" marL="0">
+            <a:pPr marL="0" indent="0" algn="r">
               <a:buNone/>
             </a:pPr>
             <a:r>
@@ -10445,7 +10180,7 @@
         </p:nvSpPr>
         <p:spPr>
           <a:xfrm>
-            <a:off x="5091296" y="2044005"/>
+            <a:off x="5099922" y="2009501"/>
             <a:ext cx="842630" cy="133350"/>
           </a:xfrm>
           <a:prstGeom prst="rect">
@@ -10458,7 +10193,7 @@
           <a:bodyPr wrap="square" lIns="0" tIns="114300" rIns="114300" bIns="0" rtlCol="0" anchor="ctr"/>
           <a:lstStyle/>
           <a:p>
-            <a:pPr algn="r" indent="0" marL="0">
+            <a:pPr marL="0" indent="0" algn="r">
               <a:buNone/>
             </a:pPr>
             <a:r>
@@ -10484,7 +10219,7 @@
         </p:nvSpPr>
         <p:spPr>
           <a:xfrm>
-            <a:off x="7532357" y="2044005"/>
+            <a:off x="7566861" y="2018127"/>
             <a:ext cx="1019986" cy="133350"/>
           </a:xfrm>
           <a:prstGeom prst="rect">
@@ -10497,7 +10232,7 @@
           <a:bodyPr wrap="square" lIns="0" tIns="114300" rIns="114300" bIns="0" rtlCol="0" anchor="ctr"/>
           <a:lstStyle/>
           <a:p>
-            <a:pPr algn="r" indent="0" marL="0">
+            <a:pPr marL="0" indent="0" algn="r">
               <a:buNone/>
             </a:pPr>
             <a:r>
@@ -10523,7 +10258,7 @@
         </p:nvSpPr>
         <p:spPr>
           <a:xfrm>
-            <a:off x="8521483" y="2044005"/>
+            <a:off x="8555987" y="2018127"/>
             <a:ext cx="1059535" cy="133350"/>
           </a:xfrm>
           <a:prstGeom prst="rect">
@@ -10536,7 +10271,7 @@
           <a:bodyPr wrap="square" lIns="0" tIns="114300" rIns="114300" bIns="0" rtlCol="0" anchor="ctr"/>
           <a:lstStyle/>
           <a:p>
-            <a:pPr algn="r" indent="0" marL="0">
+            <a:pPr marL="0" indent="0" algn="r">
               <a:buNone/>
             </a:pPr>
             <a:r>
@@ -10562,7 +10297,7 @@
         </p:nvSpPr>
         <p:spPr>
           <a:xfrm>
-            <a:off x="10564564" y="2044005"/>
+            <a:off x="10599068" y="2018127"/>
             <a:ext cx="941349" cy="133350"/>
           </a:xfrm>
           <a:prstGeom prst="rect">
@@ -10575,7 +10310,7 @@
           <a:bodyPr wrap="square" lIns="0" tIns="114300" rIns="114300" bIns="0" rtlCol="0" anchor="ctr"/>
           <a:lstStyle/>
           <a:p>
-            <a:pPr algn="r" indent="0" marL="0">
+            <a:pPr marL="0" indent="0" algn="r">
               <a:buNone/>
             </a:pPr>
             <a:r>
@@ -10614,7 +10349,7 @@
           <a:bodyPr wrap="square" lIns="0" tIns="114300" rIns="114300" bIns="0" rtlCol="0" anchor="ctr"/>
           <a:lstStyle/>
           <a:p>
-            <a:pPr algn="r" indent="0" marL="0">
+            <a:pPr marL="0" indent="0" algn="r">
               <a:buNone/>
             </a:pPr>
             <a:r>
@@ -10653,7 +10388,7 @@
           <a:bodyPr wrap="square" lIns="0" tIns="114300" rIns="114300" bIns="0" rtlCol="0" anchor="ctr"/>
           <a:lstStyle/>
           <a:p>
-            <a:pPr algn="r" indent="0" marL="0">
+            <a:pPr marL="0" indent="0" algn="r">
               <a:buNone/>
             </a:pPr>
             <a:r>
@@ -10692,7 +10427,7 @@
           <a:bodyPr wrap="square" lIns="0" tIns="0" rIns="0" bIns="0" rtlCol="0" anchor="t"/>
           <a:lstStyle/>
           <a:p>
-            <a:pPr algn="l" indent="0" marL="0">
+            <a:pPr marL="0" indent="0" algn="l">
               <a:buNone/>
             </a:pPr>
             <a:r>
@@ -10731,7 +10466,7 @@
           <a:bodyPr wrap="square" lIns="0" tIns="114300" rIns="114300" bIns="0" rtlCol="0" anchor="ctr"/>
           <a:lstStyle/>
           <a:p>
-            <a:pPr algn="r" indent="0" marL="0">
+            <a:pPr marL="0" indent="0" algn="r">
               <a:buNone/>
             </a:pPr>
             <a:r>
@@ -10757,7 +10492,7 @@
         </p:nvSpPr>
         <p:spPr>
           <a:xfrm>
-            <a:off x="4183994" y="2323951"/>
+            <a:off x="4132238" y="2254943"/>
             <a:ext cx="931845" cy="133350"/>
           </a:xfrm>
           <a:prstGeom prst="rect">
@@ -10770,7 +10505,7 @@
           <a:bodyPr wrap="square" lIns="0" tIns="114300" rIns="114300" bIns="0" rtlCol="0" anchor="ctr"/>
           <a:lstStyle/>
           <a:p>
-            <a:pPr algn="r" indent="0" marL="0">
+            <a:pPr marL="0" indent="0" algn="r">
               <a:buNone/>
             </a:pPr>
             <a:r>
@@ -10796,7 +10531,7 @@
         </p:nvSpPr>
         <p:spPr>
           <a:xfrm>
-            <a:off x="5091296" y="2352526"/>
+            <a:off x="5039540" y="2283518"/>
             <a:ext cx="842630" cy="123825"/>
           </a:xfrm>
           <a:prstGeom prst="rect">
@@ -10809,7 +10544,7 @@
           <a:bodyPr wrap="square" lIns="0" tIns="114300" rIns="114300" bIns="0" rtlCol="0" anchor="ctr"/>
           <a:lstStyle/>
           <a:p>
-            <a:pPr algn="r" indent="0" marL="0">
+            <a:pPr marL="0" indent="0" algn="r">
               <a:buNone/>
             </a:pPr>
             <a:r>
@@ -10848,7 +10583,7 @@
           <a:bodyPr wrap="square" lIns="0" tIns="114300" rIns="114300" bIns="0" rtlCol="0" anchor="ctr"/>
           <a:lstStyle/>
           <a:p>
-            <a:pPr algn="r" indent="0" marL="0">
+            <a:pPr marL="0" indent="0" algn="r">
               <a:buNone/>
             </a:pPr>
             <a:r>
@@ -10874,7 +10609,7 @@
         </p:nvSpPr>
         <p:spPr>
           <a:xfrm>
-            <a:off x="4183994" y="2713732"/>
+            <a:off x="4132238" y="2644724"/>
             <a:ext cx="931845" cy="133350"/>
           </a:xfrm>
           <a:prstGeom prst="rect">
@@ -10887,7 +10622,7 @@
           <a:bodyPr wrap="square" lIns="0" tIns="114300" rIns="114300" bIns="0" rtlCol="0" anchor="ctr"/>
           <a:lstStyle/>
           <a:p>
-            <a:pPr algn="r" indent="0" marL="0">
+            <a:pPr marL="0" indent="0" algn="r">
               <a:buNone/>
             </a:pPr>
             <a:r>
@@ -10913,7 +10648,7 @@
         </p:nvSpPr>
         <p:spPr>
           <a:xfrm>
-            <a:off x="5091296" y="2742307"/>
+            <a:off x="5039540" y="2673299"/>
             <a:ext cx="842630" cy="123825"/>
           </a:xfrm>
           <a:prstGeom prst="rect">
@@ -10926,7 +10661,7 @@
           <a:bodyPr wrap="square" lIns="0" tIns="114300" rIns="114300" bIns="0" rtlCol="0" anchor="ctr"/>
           <a:lstStyle/>
           <a:p>
-            <a:pPr algn="r" indent="0" marL="0">
+            <a:pPr marL="0" indent="0" algn="r">
               <a:buNone/>
             </a:pPr>
             <a:r>
@@ -10965,7 +10700,7 @@
           <a:bodyPr wrap="square" lIns="0" tIns="114300" rIns="114300" bIns="0" rtlCol="0" anchor="ctr"/>
           <a:lstStyle/>
           <a:p>
-            <a:pPr algn="r" indent="0" marL="0">
+            <a:pPr marL="0" indent="0" algn="r">
               <a:buNone/>
             </a:pPr>
             <a:r>
@@ -10991,7 +10726,7 @@
         </p:nvSpPr>
         <p:spPr>
           <a:xfrm>
-            <a:off x="4183994" y="3104555"/>
+            <a:off x="4132238" y="3035547"/>
             <a:ext cx="931845" cy="133350"/>
           </a:xfrm>
           <a:prstGeom prst="rect">
@@ -11004,7 +10739,7 @@
           <a:bodyPr wrap="square" lIns="0" tIns="114300" rIns="114300" bIns="0" rtlCol="0" anchor="ctr"/>
           <a:lstStyle/>
           <a:p>
-            <a:pPr algn="r" indent="0" marL="0">
+            <a:pPr marL="0" indent="0" algn="r">
               <a:buNone/>
             </a:pPr>
             <a:r>
@@ -11030,7 +10765,7 @@
         </p:nvSpPr>
         <p:spPr>
           <a:xfrm>
-            <a:off x="5091296" y="3133130"/>
+            <a:off x="5039540" y="3064122"/>
             <a:ext cx="842630" cy="123825"/>
           </a:xfrm>
           <a:prstGeom prst="rect">
@@ -11043,7 +10778,7 @@
           <a:bodyPr wrap="square" lIns="0" tIns="114300" rIns="114300" bIns="0" rtlCol="0" anchor="ctr"/>
           <a:lstStyle/>
           <a:p>
-            <a:pPr algn="r" indent="0" marL="0">
+            <a:pPr marL="0" indent="0" algn="r">
               <a:buNone/>
             </a:pPr>
             <a:r>
@@ -11082,7 +10817,7 @@
           <a:bodyPr wrap="square" lIns="0" tIns="114300" rIns="114300" bIns="0" rtlCol="0" anchor="ctr"/>
           <a:lstStyle/>
           <a:p>
-            <a:pPr algn="r" indent="0" marL="0">
+            <a:pPr marL="0" indent="0" algn="r">
               <a:buNone/>
             </a:pPr>
             <a:r>
@@ -11108,7 +10843,7 @@
         </p:nvSpPr>
         <p:spPr>
           <a:xfrm>
-            <a:off x="4183994" y="3495377"/>
+            <a:off x="4132238" y="3426369"/>
             <a:ext cx="931845" cy="133350"/>
           </a:xfrm>
           <a:prstGeom prst="rect">
@@ -11121,7 +10856,7 @@
           <a:bodyPr wrap="square" lIns="0" tIns="114300" rIns="114300" bIns="0" rtlCol="0" anchor="ctr"/>
           <a:lstStyle/>
           <a:p>
-            <a:pPr algn="r" indent="0" marL="0">
+            <a:pPr marL="0" indent="0" algn="r">
               <a:buNone/>
             </a:pPr>
             <a:r>
@@ -11147,7 +10882,7 @@
         </p:nvSpPr>
         <p:spPr>
           <a:xfrm>
-            <a:off x="5091296" y="3523952"/>
+            <a:off x="5039540" y="3454944"/>
             <a:ext cx="842630" cy="123825"/>
           </a:xfrm>
           <a:prstGeom prst="rect">
@@ -11160,7 +10895,7 @@
           <a:bodyPr wrap="square" lIns="0" tIns="114300" rIns="114300" bIns="0" rtlCol="0" anchor="ctr"/>
           <a:lstStyle/>
           <a:p>
-            <a:pPr algn="r" indent="0" marL="0">
+            <a:pPr marL="0" indent="0" algn="r">
               <a:buNone/>
             </a:pPr>
             <a:r>
@@ -11199,7 +10934,7 @@
           <a:bodyPr wrap="square" lIns="0" tIns="114300" rIns="114300" bIns="0" rtlCol="0" anchor="ctr"/>
           <a:lstStyle/>
           <a:p>
-            <a:pPr algn="r" indent="0" marL="0">
+            <a:pPr marL="0" indent="0" algn="r">
               <a:buNone/>
             </a:pPr>
             <a:r>
@@ -11225,7 +10960,7 @@
         </p:nvSpPr>
         <p:spPr>
           <a:xfrm>
-            <a:off x="4183994" y="3886200"/>
+            <a:off x="4132238" y="3817192"/>
             <a:ext cx="931845" cy="133350"/>
           </a:xfrm>
           <a:prstGeom prst="rect">
@@ -11238,7 +10973,7 @@
           <a:bodyPr wrap="square" lIns="0" tIns="114300" rIns="114300" bIns="0" rtlCol="0" anchor="ctr"/>
           <a:lstStyle/>
           <a:p>
-            <a:pPr algn="r" indent="0" marL="0">
+            <a:pPr marL="0" indent="0" algn="r">
               <a:buNone/>
             </a:pPr>
             <a:r>
@@ -11264,7 +10999,7 @@
         </p:nvSpPr>
         <p:spPr>
           <a:xfrm>
-            <a:off x="5091296" y="3914775"/>
+            <a:off x="5039540" y="3845767"/>
             <a:ext cx="842630" cy="123825"/>
           </a:xfrm>
           <a:prstGeom prst="rect">
@@ -11277,7 +11012,7 @@
           <a:bodyPr wrap="square" lIns="0" tIns="114300" rIns="114300" bIns="0" rtlCol="0" anchor="ctr"/>
           <a:lstStyle/>
           <a:p>
-            <a:pPr algn="r" indent="0" marL="0">
+            <a:pPr marL="0" indent="0" algn="r">
               <a:buNone/>
             </a:pPr>
             <a:r>
@@ -11316,7 +11051,7 @@
           <a:bodyPr wrap="square" lIns="0" tIns="114300" rIns="114300" bIns="0" rtlCol="0" anchor="ctr"/>
           <a:lstStyle/>
           <a:p>
-            <a:pPr algn="r" indent="0" marL="0">
+            <a:pPr marL="0" indent="0" algn="r">
               <a:buNone/>
             </a:pPr>
             <a:r>
@@ -11342,7 +11077,7 @@
         </p:nvSpPr>
         <p:spPr>
           <a:xfrm>
-            <a:off x="4183994" y="4277023"/>
+            <a:off x="4132238" y="4208015"/>
             <a:ext cx="931845" cy="133350"/>
           </a:xfrm>
           <a:prstGeom prst="rect">
@@ -11355,7 +11090,7 @@
           <a:bodyPr wrap="square" lIns="0" tIns="114300" rIns="114300" bIns="0" rtlCol="0" anchor="ctr"/>
           <a:lstStyle/>
           <a:p>
-            <a:pPr algn="r" indent="0" marL="0">
+            <a:pPr marL="0" indent="0" algn="r">
               <a:buNone/>
             </a:pPr>
             <a:r>
@@ -11381,7 +11116,7 @@
         </p:nvSpPr>
         <p:spPr>
           <a:xfrm>
-            <a:off x="5091296" y="4305598"/>
+            <a:off x="5039540" y="4236590"/>
             <a:ext cx="842630" cy="123825"/>
           </a:xfrm>
           <a:prstGeom prst="rect">
@@ -11394,7 +11129,7 @@
           <a:bodyPr wrap="square" lIns="0" tIns="114300" rIns="114300" bIns="0" rtlCol="0" anchor="ctr"/>
           <a:lstStyle/>
           <a:p>
-            <a:pPr algn="r" indent="0" marL="0">
+            <a:pPr marL="0" indent="0" algn="r">
               <a:buNone/>
             </a:pPr>
             <a:r>
@@ -11433,7 +11168,7 @@
           <a:bodyPr wrap="square" lIns="0" tIns="114300" rIns="114300" bIns="0" rtlCol="0" anchor="ctr"/>
           <a:lstStyle/>
           <a:p>
-            <a:pPr algn="r" indent="0" marL="0">
+            <a:pPr marL="0" indent="0" algn="r">
               <a:buNone/>
             </a:pPr>
             <a:r>
@@ -11459,7 +11194,7 @@
         </p:nvSpPr>
         <p:spPr>
           <a:xfrm>
-            <a:off x="4183994" y="4667845"/>
+            <a:off x="4132238" y="4598837"/>
             <a:ext cx="931845" cy="133350"/>
           </a:xfrm>
           <a:prstGeom prst="rect">
@@ -11472,7 +11207,7 @@
           <a:bodyPr wrap="square" lIns="0" tIns="114300" rIns="114300" bIns="0" rtlCol="0" anchor="ctr"/>
           <a:lstStyle/>
           <a:p>
-            <a:pPr algn="r" indent="0" marL="0">
+            <a:pPr marL="0" indent="0" algn="r">
               <a:buNone/>
             </a:pPr>
             <a:r>
@@ -11498,7 +11233,7 @@
         </p:nvSpPr>
         <p:spPr>
           <a:xfrm>
-            <a:off x="5091296" y="4696420"/>
+            <a:off x="5039540" y="4627412"/>
             <a:ext cx="842630" cy="123825"/>
           </a:xfrm>
           <a:prstGeom prst="rect">
@@ -11511,7 +11246,7 @@
           <a:bodyPr wrap="square" lIns="0" tIns="114300" rIns="114300" bIns="0" rtlCol="0" anchor="ctr"/>
           <a:lstStyle/>
           <a:p>
-            <a:pPr algn="r" indent="0" marL="0">
+            <a:pPr marL="0" indent="0" algn="r">
               <a:buNone/>
             </a:pPr>
             <a:r>
@@ -11550,7 +11285,7 @@
           <a:bodyPr wrap="square" lIns="0" tIns="114300" rIns="114300" bIns="0" rtlCol="0" anchor="ctr"/>
           <a:lstStyle/>
           <a:p>
-            <a:pPr algn="r" indent="0" marL="0">
+            <a:pPr marL="0" indent="0" algn="r">
               <a:buNone/>
             </a:pPr>
             <a:r>
@@ -11576,7 +11311,7 @@
         </p:nvSpPr>
         <p:spPr>
           <a:xfrm>
-            <a:off x="4183994" y="5058668"/>
+            <a:off x="4132238" y="4989660"/>
             <a:ext cx="931845" cy="133350"/>
           </a:xfrm>
           <a:prstGeom prst="rect">
@@ -11589,7 +11324,7 @@
           <a:bodyPr wrap="square" lIns="0" tIns="114300" rIns="114300" bIns="0" rtlCol="0" anchor="ctr"/>
           <a:lstStyle/>
           <a:p>
-            <a:pPr algn="r" indent="0" marL="0">
+            <a:pPr marL="0" indent="0" algn="r">
               <a:buNone/>
             </a:pPr>
             <a:r>
@@ -11615,7 +11350,7 @@
         </p:nvSpPr>
         <p:spPr>
           <a:xfrm>
-            <a:off x="5091296" y="5087243"/>
+            <a:off x="5039540" y="5018235"/>
             <a:ext cx="842630" cy="123825"/>
           </a:xfrm>
           <a:prstGeom prst="rect">
@@ -11628,7 +11363,7 @@
           <a:bodyPr wrap="square" lIns="0" tIns="114300" rIns="114300" bIns="0" rtlCol="0" anchor="ctr"/>
           <a:lstStyle/>
           <a:p>
-            <a:pPr algn="r" indent="0" marL="0">
+            <a:pPr marL="0" indent="0" algn="r">
               <a:buNone/>
             </a:pPr>
             <a:r>
@@ -11654,7 +11389,7 @@
         </p:nvSpPr>
         <p:spPr>
           <a:xfrm>
-            <a:off x="5091296" y="5463332"/>
+            <a:off x="5039540" y="5394324"/>
             <a:ext cx="842630" cy="123825"/>
           </a:xfrm>
           <a:prstGeom prst="rect">
@@ -11667,7 +11402,7 @@
           <a:bodyPr wrap="square" lIns="0" tIns="114300" rIns="114300" bIns="0" rtlCol="0" anchor="ctr"/>
           <a:lstStyle/>
           <a:p>
-            <a:pPr algn="r" indent="0" marL="0">
+            <a:pPr marL="0" indent="0" algn="r">
               <a:buNone/>
             </a:pPr>
             <a:r>
@@ -11693,7 +11428,7 @@
         </p:nvSpPr>
         <p:spPr>
           <a:xfrm>
-            <a:off x="10564564" y="2352526"/>
+            <a:off x="10504182" y="2292144"/>
             <a:ext cx="941349" cy="123825"/>
           </a:xfrm>
           <a:prstGeom prst="rect">
@@ -11706,7 +11441,7 @@
           <a:bodyPr wrap="square" lIns="0" tIns="114300" rIns="114300" bIns="0" rtlCol="0" anchor="ctr"/>
           <a:lstStyle/>
           <a:p>
-            <a:pPr algn="r" indent="0" marL="0">
+            <a:pPr marL="0" indent="0" algn="r">
               <a:buNone/>
             </a:pPr>
             <a:r>
@@ -11732,7 +11467,7 @@
         </p:nvSpPr>
         <p:spPr>
           <a:xfrm>
-            <a:off x="10564564" y="2742307"/>
+            <a:off x="10504182" y="2681925"/>
             <a:ext cx="941349" cy="123825"/>
           </a:xfrm>
           <a:prstGeom prst="rect">
@@ -11745,7 +11480,7 @@
           <a:bodyPr wrap="square" lIns="0" tIns="114300" rIns="114300" bIns="0" rtlCol="0" anchor="ctr"/>
           <a:lstStyle/>
           <a:p>
-            <a:pPr algn="r" indent="0" marL="0">
+            <a:pPr marL="0" indent="0" algn="r">
               <a:buNone/>
             </a:pPr>
             <a:r>
@@ -11771,7 +11506,7 @@
         </p:nvSpPr>
         <p:spPr>
           <a:xfrm>
-            <a:off x="10564564" y="3133130"/>
+            <a:off x="10504182" y="3072748"/>
             <a:ext cx="941349" cy="123825"/>
           </a:xfrm>
           <a:prstGeom prst="rect">
@@ -11784,7 +11519,7 @@
           <a:bodyPr wrap="square" lIns="0" tIns="114300" rIns="114300" bIns="0" rtlCol="0" anchor="ctr"/>
           <a:lstStyle/>
           <a:p>
-            <a:pPr algn="r" indent="0" marL="0">
+            <a:pPr marL="0" indent="0" algn="r">
               <a:buNone/>
             </a:pPr>
             <a:r>
@@ -11810,7 +11545,7 @@
         </p:nvSpPr>
         <p:spPr>
           <a:xfrm>
-            <a:off x="10564564" y="3523952"/>
+            <a:off x="10504182" y="3463570"/>
             <a:ext cx="941349" cy="123825"/>
           </a:xfrm>
           <a:prstGeom prst="rect">
@@ -11823,7 +11558,7 @@
           <a:bodyPr wrap="square" lIns="0" tIns="114300" rIns="114300" bIns="0" rtlCol="0" anchor="ctr"/>
           <a:lstStyle/>
           <a:p>
-            <a:pPr algn="r" indent="0" marL="0">
+            <a:pPr marL="0" indent="0" algn="r">
               <a:buNone/>
             </a:pPr>
             <a:r>
@@ -11849,7 +11584,7 @@
         </p:nvSpPr>
         <p:spPr>
           <a:xfrm>
-            <a:off x="10564564" y="3914775"/>
+            <a:off x="10504182" y="3854393"/>
             <a:ext cx="941349" cy="123825"/>
           </a:xfrm>
           <a:prstGeom prst="rect">
@@ -11862,7 +11597,7 @@
           <a:bodyPr wrap="square" lIns="0" tIns="114300" rIns="114300" bIns="0" rtlCol="0" anchor="ctr"/>
           <a:lstStyle/>
           <a:p>
-            <a:pPr algn="r" indent="0" marL="0">
+            <a:pPr marL="0" indent="0" algn="r">
               <a:buNone/>
             </a:pPr>
             <a:r>
@@ -11888,7 +11623,7 @@
         </p:nvSpPr>
         <p:spPr>
           <a:xfrm>
-            <a:off x="10564564" y="4305598"/>
+            <a:off x="10504182" y="4245216"/>
             <a:ext cx="941349" cy="123825"/>
           </a:xfrm>
           <a:prstGeom prst="rect">
@@ -11901,7 +11636,7 @@
           <a:bodyPr wrap="square" lIns="0" tIns="114300" rIns="114300" bIns="0" rtlCol="0" anchor="ctr"/>
           <a:lstStyle/>
           <a:p>
-            <a:pPr algn="r" indent="0" marL="0">
+            <a:pPr marL="0" indent="0" algn="r">
               <a:buNone/>
             </a:pPr>
             <a:r>
@@ -11927,7 +11662,7 @@
         </p:nvSpPr>
         <p:spPr>
           <a:xfrm>
-            <a:off x="10564564" y="4696420"/>
+            <a:off x="10504182" y="4636038"/>
             <a:ext cx="941349" cy="123825"/>
           </a:xfrm>
           <a:prstGeom prst="rect">
@@ -11940,7 +11675,7 @@
           <a:bodyPr wrap="square" lIns="0" tIns="114300" rIns="114300" bIns="0" rtlCol="0" anchor="ctr"/>
           <a:lstStyle/>
           <a:p>
-            <a:pPr algn="r" indent="0" marL="0">
+            <a:pPr marL="0" indent="0" algn="r">
               <a:buNone/>
             </a:pPr>
             <a:r>
@@ -11966,7 +11701,7 @@
         </p:nvSpPr>
         <p:spPr>
           <a:xfrm>
-            <a:off x="10564564" y="5087243"/>
+            <a:off x="10504182" y="5026861"/>
             <a:ext cx="941349" cy="123825"/>
           </a:xfrm>
           <a:prstGeom prst="rect">
@@ -11979,7 +11714,7 @@
           <a:bodyPr wrap="square" lIns="0" tIns="114300" rIns="114300" bIns="0" rtlCol="0" anchor="ctr"/>
           <a:lstStyle/>
           <a:p>
-            <a:pPr algn="r" indent="0" marL="0">
+            <a:pPr marL="0" indent="0" algn="r">
               <a:buNone/>
             </a:pPr>
             <a:r>
@@ -12005,7 +11740,7 @@
         </p:nvSpPr>
         <p:spPr>
           <a:xfrm>
-            <a:off x="10564564" y="5463332"/>
+            <a:off x="10504182" y="5402950"/>
             <a:ext cx="941349" cy="123825"/>
           </a:xfrm>
           <a:prstGeom prst="rect">
@@ -12018,7 +11753,7 @@
           <a:bodyPr wrap="square" lIns="0" tIns="114300" rIns="114300" bIns="0" rtlCol="0" anchor="ctr"/>
           <a:lstStyle/>
           <a:p>
-            <a:pPr algn="r" indent="0" marL="0">
+            <a:pPr marL="0" indent="0" algn="r">
               <a:buNone/>
             </a:pPr>
             <a:r>
@@ -12057,7 +11792,7 @@
           <a:bodyPr wrap="square" lIns="0" tIns="0" rIns="0" bIns="0" rtlCol="0" anchor="t"/>
           <a:lstStyle/>
           <a:p>
-            <a:pPr algn="l" indent="0" marL="0">
+            <a:pPr marL="0" indent="0" algn="l">
               <a:buNone/>
             </a:pPr>
             <a:r>
@@ -12096,7 +11831,7 @@
           <a:bodyPr wrap="square" lIns="0" tIns="0" rIns="0" bIns="0" rtlCol="0" anchor="t"/>
           <a:lstStyle/>
           <a:p>
-            <a:pPr algn="l" indent="0" marL="0">
+            <a:pPr marL="0" indent="0" algn="l">
               <a:buNone/>
             </a:pPr>
             <a:r>
@@ -12135,7 +11870,7 @@
           <a:bodyPr wrap="square" lIns="0" tIns="114300" rIns="114300" bIns="0" rtlCol="0" anchor="ctr"/>
           <a:lstStyle/>
           <a:p>
-            <a:pPr algn="r" indent="0" marL="0">
+            <a:pPr marL="0" indent="0" algn="r">
               <a:buNone/>
             </a:pPr>
             <a:r>
@@ -12174,7 +11909,7 @@
           <a:bodyPr wrap="square" lIns="0" tIns="114300" rIns="114300" bIns="0" rtlCol="0" anchor="ctr"/>
           <a:lstStyle/>
           <a:p>
-            <a:pPr algn="r" indent="0" marL="0">
+            <a:pPr marL="0" indent="0" algn="r">
               <a:buNone/>
             </a:pPr>
             <a:r>
@@ -12200,7 +11935,7 @@
         </p:nvSpPr>
         <p:spPr>
           <a:xfrm>
-            <a:off x="685783" y="2044005"/>
+            <a:off x="694409" y="2009501"/>
             <a:ext cx="1202400" cy="133350"/>
           </a:xfrm>
           <a:prstGeom prst="rect">
@@ -12213,7 +11948,7 @@
           <a:bodyPr wrap="square" lIns="0" tIns="114300" rIns="114300" bIns="0" rtlCol="0" anchor="ctr"/>
           <a:lstStyle/>
           <a:p>
-            <a:pPr algn="l" indent="0" marL="0">
+            <a:pPr marL="0" indent="0" algn="l">
               <a:buNone/>
             </a:pPr>
             <a:r>
@@ -12239,7 +11974,7 @@
         </p:nvSpPr>
         <p:spPr>
           <a:xfrm>
-            <a:off x="2722878" y="2044005"/>
+            <a:off x="2731504" y="2009501"/>
             <a:ext cx="567630" cy="133350"/>
           </a:xfrm>
           <a:prstGeom prst="rect">
@@ -12252,7 +11987,7 @@
           <a:bodyPr wrap="square" lIns="0" tIns="114300" rIns="114300" bIns="0" rtlCol="0" anchor="ctr"/>
           <a:lstStyle/>
           <a:p>
-            <a:pPr algn="r" indent="0" marL="0">
+            <a:pPr marL="0" indent="0" algn="r">
               <a:buNone/>
             </a:pPr>
             <a:r>
@@ -12291,7 +12026,7 @@
           <a:bodyPr wrap="square" lIns="0" tIns="114300" rIns="114300" bIns="0" rtlCol="0" anchor="ctr"/>
           <a:lstStyle/>
           <a:p>
-            <a:pPr algn="l" indent="0" marL="0">
+            <a:pPr marL="0" indent="0" algn="l">
               <a:buNone/>
             </a:pPr>
             <a:r>
@@ -12330,7 +12065,7 @@
           <a:bodyPr wrap="square" lIns="0" tIns="114300" rIns="114300" bIns="0" rtlCol="0" anchor="ctr"/>
           <a:lstStyle/>
           <a:p>
-            <a:pPr algn="r" indent="0" marL="0">
+            <a:pPr marL="0" indent="0" algn="r">
               <a:buNone/>
             </a:pPr>
             <a:r>
@@ -12369,7 +12104,7 @@
           <a:bodyPr wrap="square" lIns="0" tIns="114300" rIns="114300" bIns="0" rtlCol="0" anchor="ctr"/>
           <a:lstStyle/>
           <a:p>
-            <a:pPr algn="l" indent="0" marL="0">
+            <a:pPr marL="0" indent="0" algn="l">
               <a:buNone/>
             </a:pPr>
             <a:r>
@@ -12408,7 +12143,7 @@
           <a:bodyPr wrap="square" lIns="0" tIns="114300" rIns="114300" bIns="0" rtlCol="0" anchor="ctr"/>
           <a:lstStyle/>
           <a:p>
-            <a:pPr algn="r" indent="0" marL="0">
+            <a:pPr marL="0" indent="0" algn="r">
               <a:buNone/>
             </a:pPr>
             <a:r>
@@ -12447,7 +12182,7 @@
           <a:bodyPr wrap="square" lIns="0" tIns="114300" rIns="114300" bIns="0" rtlCol="0" anchor="ctr"/>
           <a:lstStyle/>
           <a:p>
-            <a:pPr algn="l" indent="0" marL="0">
+            <a:pPr marL="0" indent="0" algn="l">
               <a:buNone/>
             </a:pPr>
             <a:r>
@@ -12486,7 +12221,7 @@
           <a:bodyPr wrap="square" lIns="0" tIns="114300" rIns="114300" bIns="0" rtlCol="0" anchor="ctr"/>
           <a:lstStyle/>
           <a:p>
-            <a:pPr algn="r" indent="0" marL="0">
+            <a:pPr marL="0" indent="0" algn="r">
               <a:buNone/>
             </a:pPr>
             <a:r>
@@ -12525,7 +12260,7 @@
           <a:bodyPr wrap="square" lIns="0" tIns="114300" rIns="114300" bIns="0" rtlCol="0" anchor="ctr"/>
           <a:lstStyle/>
           <a:p>
-            <a:pPr algn="l" indent="0" marL="0">
+            <a:pPr marL="0" indent="0" algn="l">
               <a:buNone/>
             </a:pPr>
             <a:r>
@@ -12564,7 +12299,7 @@
           <a:bodyPr wrap="square" lIns="0" tIns="114300" rIns="114300" bIns="0" rtlCol="0" anchor="ctr"/>
           <a:lstStyle/>
           <a:p>
-            <a:pPr algn="r" indent="0" marL="0">
+            <a:pPr marL="0" indent="0" algn="r">
               <a:buNone/>
             </a:pPr>
             <a:r>
@@ -12603,7 +12338,7 @@
           <a:bodyPr wrap="square" lIns="0" tIns="114300" rIns="114300" bIns="0" rtlCol="0" anchor="ctr"/>
           <a:lstStyle/>
           <a:p>
-            <a:pPr algn="l" indent="0" marL="0">
+            <a:pPr marL="0" indent="0" algn="l">
               <a:buNone/>
             </a:pPr>
             <a:r>
@@ -12642,7 +12377,7 @@
           <a:bodyPr wrap="square" lIns="0" tIns="114300" rIns="114300" bIns="0" rtlCol="0" anchor="ctr"/>
           <a:lstStyle/>
           <a:p>
-            <a:pPr algn="l" indent="0" marL="0">
+            <a:pPr marL="0" indent="0" algn="l">
               <a:buNone/>
             </a:pPr>
             <a:r>
@@ -12681,7 +12416,7 @@
           <a:bodyPr wrap="square" lIns="0" tIns="114300" rIns="114300" bIns="0" rtlCol="0" anchor="ctr"/>
           <a:lstStyle/>
           <a:p>
-            <a:pPr algn="l" indent="0" marL="0">
+            <a:pPr marL="0" indent="0" algn="l">
               <a:buNone/>
             </a:pPr>
             <a:r>
@@ -12720,7 +12455,7 @@
           <a:bodyPr wrap="square" lIns="0" tIns="114300" rIns="114300" bIns="0" rtlCol="0" anchor="ctr"/>
           <a:lstStyle/>
           <a:p>
-            <a:pPr algn="l" indent="0" marL="0">
+            <a:pPr marL="0" indent="0" algn="l">
               <a:buNone/>
             </a:pPr>
             <a:r>
@@ -12759,7 +12494,7 @@
           <a:bodyPr wrap="square" lIns="0" tIns="114300" rIns="114300" bIns="0" rtlCol="0" anchor="ctr"/>
           <a:lstStyle/>
           <a:p>
-            <a:pPr algn="r" indent="0" marL="0">
+            <a:pPr marL="0" indent="0" algn="r">
               <a:buNone/>
             </a:pPr>
             <a:r>
@@ -12785,7 +12520,7 @@
         </p:nvSpPr>
         <p:spPr>
           <a:xfrm>
-            <a:off x="6257769" y="2044005"/>
+            <a:off x="6292273" y="2018127"/>
             <a:ext cx="1343426" cy="133350"/>
           </a:xfrm>
           <a:prstGeom prst="rect">
@@ -12798,7 +12533,7 @@
           <a:bodyPr wrap="square" lIns="0" tIns="114300" rIns="114300" bIns="0" rtlCol="0" anchor="ctr"/>
           <a:lstStyle/>
           <a:p>
-            <a:pPr algn="l" indent="0" marL="0">
+            <a:pPr marL="0" indent="0" algn="l">
               <a:buNone/>
             </a:pPr>
             <a:r>
@@ -12837,7 +12572,7 @@
           <a:bodyPr wrap="square" lIns="0" tIns="114300" rIns="114300" bIns="0" rtlCol="0" anchor="ctr"/>
           <a:lstStyle/>
           <a:p>
-            <a:pPr algn="l" indent="0" marL="0">
+            <a:pPr marL="0" indent="0" algn="l">
               <a:buNone/>
             </a:pPr>
             <a:r>
@@ -12876,7 +12611,7 @@
           <a:bodyPr wrap="square" lIns="0" tIns="114300" rIns="114300" bIns="0" rtlCol="0" anchor="ctr"/>
           <a:lstStyle/>
           <a:p>
-            <a:pPr algn="r" indent="0" marL="0">
+            <a:pPr marL="0" indent="0" algn="r">
               <a:buNone/>
             </a:pPr>
             <a:r>
@@ -12915,7 +12650,7 @@
           <a:bodyPr wrap="square" lIns="0" tIns="114300" rIns="114300" bIns="0" rtlCol="0" anchor="ctr"/>
           <a:lstStyle/>
           <a:p>
-            <a:pPr algn="l" indent="0" marL="0">
+            <a:pPr marL="0" indent="0" algn="l">
               <a:buNone/>
             </a:pPr>
             <a:r>
@@ -12954,7 +12689,7 @@
           <a:bodyPr wrap="square" lIns="0" tIns="114300" rIns="114300" bIns="0" rtlCol="0" anchor="ctr"/>
           <a:lstStyle/>
           <a:p>
-            <a:pPr algn="r" indent="0" marL="0">
+            <a:pPr marL="0" indent="0" algn="r">
               <a:buNone/>
             </a:pPr>
             <a:r>
@@ -12993,7 +12728,7 @@
           <a:bodyPr wrap="square" lIns="0" tIns="114300" rIns="114300" bIns="0" rtlCol="0" anchor="ctr"/>
           <a:lstStyle/>
           <a:p>
-            <a:pPr algn="r" indent="0" marL="0">
+            <a:pPr marL="0" indent="0" algn="r">
               <a:buNone/>
             </a:pPr>
             <a:r>
@@ -13032,7 +12767,7 @@
           <a:bodyPr wrap="square" lIns="0" tIns="114300" rIns="114300" bIns="0" rtlCol="0" anchor="ctr"/>
           <a:lstStyle/>
           <a:p>
-            <a:pPr algn="l" indent="0" marL="0">
+            <a:pPr marL="0" indent="0" algn="l">
               <a:buNone/>
             </a:pPr>
             <a:r>
@@ -13071,7 +12806,7 @@
           <a:bodyPr wrap="square" lIns="0" tIns="114300" rIns="114300" bIns="0" rtlCol="0" anchor="ctr"/>
           <a:lstStyle/>
           <a:p>
-            <a:pPr algn="r" indent="0" marL="0">
+            <a:pPr marL="0" indent="0" algn="r">
               <a:buNone/>
             </a:pPr>
             <a:r>
@@ -13110,7 +12845,7 @@
           <a:bodyPr wrap="square" lIns="0" tIns="114300" rIns="114300" bIns="0" rtlCol="0" anchor="ctr"/>
           <a:lstStyle/>
           <a:p>
-            <a:pPr algn="r" indent="0" marL="0">
+            <a:pPr marL="0" indent="0" algn="r">
               <a:buNone/>
             </a:pPr>
             <a:r>
@@ -13136,7 +12871,7 @@
         </p:nvSpPr>
         <p:spPr>
           <a:xfrm>
-            <a:off x="9550689" y="3104555"/>
+            <a:off x="9490307" y="3044173"/>
             <a:ext cx="1041293" cy="133350"/>
           </a:xfrm>
           <a:prstGeom prst="rect">
@@ -13149,7 +12884,7 @@
           <a:bodyPr wrap="square" lIns="0" tIns="114300" rIns="114300" bIns="0" rtlCol="0" anchor="ctr"/>
           <a:lstStyle/>
           <a:p>
-            <a:pPr algn="r" indent="0" marL="0">
+            <a:pPr marL="0" indent="0" algn="r">
               <a:buNone/>
             </a:pPr>
             <a:r>
@@ -13188,7 +12923,7 @@
           <a:bodyPr wrap="square" lIns="0" tIns="114300" rIns="114300" bIns="0" rtlCol="0" anchor="ctr"/>
           <a:lstStyle/>
           <a:p>
-            <a:pPr algn="l" indent="0" marL="0">
+            <a:pPr marL="0" indent="0" algn="l">
               <a:buNone/>
             </a:pPr>
             <a:r>
@@ -13227,7 +12962,7 @@
           <a:bodyPr wrap="square" lIns="0" tIns="114300" rIns="114300" bIns="0" rtlCol="0" anchor="ctr"/>
           <a:lstStyle/>
           <a:p>
-            <a:pPr algn="r" indent="0" marL="0">
+            <a:pPr marL="0" indent="0" algn="r">
               <a:buNone/>
             </a:pPr>
             <a:r>
@@ -13266,7 +13001,7 @@
           <a:bodyPr wrap="square" lIns="0" tIns="114300" rIns="114300" bIns="0" rtlCol="0" anchor="ctr"/>
           <a:lstStyle/>
           <a:p>
-            <a:pPr algn="r" indent="0" marL="0">
+            <a:pPr marL="0" indent="0" algn="r">
               <a:buNone/>
             </a:pPr>
             <a:r>
@@ -13305,7 +13040,7 @@
           <a:bodyPr wrap="square" lIns="0" tIns="114300" rIns="114300" bIns="0" rtlCol="0" anchor="ctr"/>
           <a:lstStyle/>
           <a:p>
-            <a:pPr algn="l" indent="0" marL="0">
+            <a:pPr marL="0" indent="0" algn="l">
               <a:buNone/>
             </a:pPr>
             <a:r>
@@ -13344,7 +13079,7 @@
           <a:bodyPr wrap="square" lIns="0" tIns="114300" rIns="114300" bIns="0" rtlCol="0" anchor="ctr"/>
           <a:lstStyle/>
           <a:p>
-            <a:pPr algn="r" indent="0" marL="0">
+            <a:pPr marL="0" indent="0" algn="r">
               <a:buNone/>
             </a:pPr>
             <a:r>
@@ -13383,7 +13118,7 @@
           <a:bodyPr wrap="square" lIns="0" tIns="114300" rIns="114300" bIns="0" rtlCol="0" anchor="ctr"/>
           <a:lstStyle/>
           <a:p>
-            <a:pPr algn="l" indent="0" marL="0">
+            <a:pPr marL="0" indent="0" algn="l">
               <a:buNone/>
             </a:pPr>
             <a:r>
@@ -13422,7 +13157,7 @@
           <a:bodyPr wrap="square" lIns="0" tIns="114300" rIns="114300" bIns="0" rtlCol="0" anchor="ctr"/>
           <a:lstStyle/>
           <a:p>
-            <a:pPr algn="r" indent="0" marL="0">
+            <a:pPr marL="0" indent="0" algn="r">
               <a:buNone/>
             </a:pPr>
             <a:r>
@@ -13461,7 +13196,7 @@
           <a:bodyPr wrap="square" lIns="0" tIns="114300" rIns="114300" bIns="0" rtlCol="0" anchor="ctr"/>
           <a:lstStyle/>
           <a:p>
-            <a:pPr algn="l" indent="0" marL="0">
+            <a:pPr marL="0" indent="0" algn="l">
               <a:buNone/>
             </a:pPr>
             <a:r>
@@ -13500,7 +13235,7 @@
           <a:bodyPr wrap="square" lIns="0" tIns="114300" rIns="114300" bIns="0" rtlCol="0" anchor="ctr"/>
           <a:lstStyle/>
           <a:p>
-            <a:pPr algn="l" indent="0" marL="0">
+            <a:pPr marL="0" indent="0" algn="l">
               <a:buNone/>
             </a:pPr>
             <a:r>
@@ -13539,7 +13274,7 @@
           <a:bodyPr wrap="square" lIns="0" tIns="114300" rIns="114300" bIns="0" rtlCol="0" anchor="ctr"/>
           <a:lstStyle/>
           <a:p>
-            <a:pPr algn="r" indent="0" marL="0">
+            <a:pPr marL="0" indent="0" algn="r">
               <a:buNone/>
             </a:pPr>
             <a:r>
@@ -13578,7 +13313,7 @@
           <a:bodyPr wrap="square" lIns="0" tIns="114300" rIns="114300" bIns="0" rtlCol="0" anchor="ctr"/>
           <a:lstStyle/>
           <a:p>
-            <a:pPr algn="r" indent="0" marL="0">
+            <a:pPr marL="0" indent="0" algn="r">
               <a:buNone/>
             </a:pPr>
             <a:r>
@@ -13617,7 +13352,7 @@
           <a:bodyPr wrap="square" lIns="0" tIns="0" rIns="0" bIns="0" rtlCol="0" anchor="t"/>
           <a:lstStyle/>
           <a:p>
-            <a:pPr algn="l" indent="0" marL="0">
+            <a:pPr marL="0" indent="0" algn="l">
               <a:buNone/>
             </a:pPr>
             <a:r>
@@ -13656,7 +13391,7 @@
           <a:bodyPr wrap="square" lIns="0" tIns="114300" rIns="114300" bIns="0" rtlCol="0" anchor="ctr"/>
           <a:lstStyle/>
           <a:p>
-            <a:pPr algn="r" indent="0" marL="0">
+            <a:pPr marL="0" indent="0" algn="r">
               <a:buNone/>
             </a:pPr>
             <a:r>
@@ -13695,7 +13430,7 @@
           <a:bodyPr wrap="square" lIns="0" tIns="114300" rIns="114300" bIns="0" rtlCol="0" anchor="ctr"/>
           <a:lstStyle/>
           <a:p>
-            <a:pPr algn="r" indent="0" marL="0">
+            <a:pPr marL="0" indent="0" algn="r">
               <a:buNone/>
             </a:pPr>
             <a:r>
@@ -13734,7 +13469,7 @@
           <a:bodyPr wrap="square" lIns="0" tIns="114300" rIns="114300" bIns="0" rtlCol="0" anchor="ctr"/>
           <a:lstStyle/>
           <a:p>
-            <a:pPr algn="r" indent="0" marL="0">
+            <a:pPr marL="0" indent="0" algn="r">
               <a:buNone/>
             </a:pPr>
             <a:r>
@@ -13773,7 +13508,7 @@
           <a:bodyPr wrap="square" lIns="0" tIns="114300" rIns="114300" bIns="0" rtlCol="0" anchor="ctr"/>
           <a:lstStyle/>
           <a:p>
-            <a:pPr algn="r" indent="0" marL="0">
+            <a:pPr marL="0" indent="0" algn="r">
               <a:buNone/>
             </a:pPr>
             <a:r>
@@ -13812,7 +13547,7 @@
           <a:bodyPr wrap="square" lIns="0" tIns="114300" rIns="114300" bIns="0" rtlCol="0" anchor="ctr"/>
           <a:lstStyle/>
           <a:p>
-            <a:pPr algn="r" indent="0" marL="0">
+            <a:pPr marL="0" indent="0" algn="r">
               <a:buNone/>
             </a:pPr>
             <a:r>
@@ -13851,7 +13586,7 @@
           <a:bodyPr wrap="square" lIns="0" tIns="114300" rIns="114300" bIns="0" rtlCol="0" anchor="ctr"/>
           <a:lstStyle/>
           <a:p>
-            <a:pPr algn="r" indent="0" marL="0">
+            <a:pPr marL="0" indent="0" algn="r">
               <a:buNone/>
             </a:pPr>
             <a:r>
@@ -13890,7 +13625,7 @@
           <a:bodyPr wrap="square" lIns="0" tIns="114300" rIns="114300" bIns="0" rtlCol="0" anchor="ctr"/>
           <a:lstStyle/>
           <a:p>
-            <a:pPr algn="r" indent="0" marL="0">
+            <a:pPr marL="0" indent="0" algn="r">
               <a:buNone/>
             </a:pPr>
             <a:r>
@@ -13929,7 +13664,7 @@
           <a:bodyPr wrap="square" lIns="0" tIns="114300" rIns="114300" bIns="0" rtlCol="0" anchor="ctr"/>
           <a:lstStyle/>
           <a:p>
-            <a:pPr algn="r" indent="0" marL="0">
+            <a:pPr marL="0" indent="0" algn="r">
               <a:buNone/>
             </a:pPr>
             <a:r>
@@ -13968,7 +13703,7 @@
           <a:bodyPr wrap="square" lIns="0" tIns="114300" rIns="114300" bIns="0" rtlCol="0" anchor="ctr"/>
           <a:lstStyle/>
           <a:p>
-            <a:pPr algn="r" indent="0" marL="0">
+            <a:pPr marL="0" indent="0" algn="r">
               <a:buNone/>
             </a:pPr>
             <a:r>
@@ -14007,7 +13742,7 @@
           <a:bodyPr wrap="square" lIns="0" tIns="114300" rIns="114300" bIns="0" rtlCol="0" anchor="ctr"/>
           <a:lstStyle/>
           <a:p>
-            <a:pPr algn="r" indent="0" marL="0">
+            <a:pPr marL="0" indent="0" algn="r">
               <a:buNone/>
             </a:pPr>
             <a:r>
@@ -14046,7 +13781,7 @@
           <a:bodyPr wrap="square" lIns="0" tIns="114300" rIns="114300" bIns="0" rtlCol="0" anchor="ctr"/>
           <a:lstStyle/>
           <a:p>
-            <a:pPr algn="r" indent="0" marL="0">
+            <a:pPr marL="0" indent="0" algn="r">
               <a:buNone/>
             </a:pPr>
             <a:r>
@@ -14085,7 +13820,7 @@
           <a:bodyPr wrap="square" lIns="0" tIns="114300" rIns="114300" bIns="0" rtlCol="0" anchor="ctr"/>
           <a:lstStyle/>
           <a:p>
-            <a:pPr algn="r" indent="0" marL="0">
+            <a:pPr marL="0" indent="0" algn="r">
               <a:buNone/>
             </a:pPr>
             <a:r>
@@ -14124,7 +13859,7 @@
           <a:bodyPr wrap="square" lIns="0" tIns="114300" rIns="114300" bIns="0" rtlCol="0" anchor="ctr"/>
           <a:lstStyle/>
           <a:p>
-            <a:pPr algn="r" indent="0" marL="0">
+            <a:pPr marL="0" indent="0" algn="r">
               <a:buNone/>
             </a:pPr>
             <a:r>
@@ -14150,7 +13885,7 @@
         </p:nvSpPr>
         <p:spPr>
           <a:xfrm>
-            <a:off x="9550689" y="2323951"/>
+            <a:off x="9490307" y="2263569"/>
             <a:ext cx="1041293" cy="133350"/>
           </a:xfrm>
           <a:prstGeom prst="rect">
@@ -14163,7 +13898,7 @@
           <a:bodyPr wrap="square" lIns="0" tIns="114300" rIns="114300" bIns="0" rtlCol="0" anchor="ctr"/>
           <a:lstStyle/>
           <a:p>
-            <a:pPr algn="r" indent="0" marL="0">
+            <a:pPr marL="0" indent="0" algn="r">
               <a:buNone/>
             </a:pPr>
             <a:r>
@@ -14189,7 +13924,7 @@
         </p:nvSpPr>
         <p:spPr>
           <a:xfrm>
-            <a:off x="9550689" y="2713732"/>
+            <a:off x="9490307" y="2653350"/>
             <a:ext cx="1041293" cy="133350"/>
           </a:xfrm>
           <a:prstGeom prst="rect">
@@ -14202,7 +13937,7 @@
           <a:bodyPr wrap="square" lIns="0" tIns="114300" rIns="114300" bIns="0" rtlCol="0" anchor="ctr"/>
           <a:lstStyle/>
           <a:p>
-            <a:pPr algn="r" indent="0" marL="0">
+            <a:pPr marL="0" indent="0" algn="r">
               <a:buNone/>
             </a:pPr>
             <a:r>
@@ -14228,7 +13963,7 @@
         </p:nvSpPr>
         <p:spPr>
           <a:xfrm>
-            <a:off x="9550689" y="3495377"/>
+            <a:off x="9490307" y="3434995"/>
             <a:ext cx="1041293" cy="133350"/>
           </a:xfrm>
           <a:prstGeom prst="rect">
@@ -14241,7 +13976,7 @@
           <a:bodyPr wrap="square" lIns="0" tIns="114300" rIns="114300" bIns="0" rtlCol="0" anchor="ctr"/>
           <a:lstStyle/>
           <a:p>
-            <a:pPr algn="r" indent="0" marL="0">
+            <a:pPr marL="0" indent="0" algn="r">
               <a:buNone/>
             </a:pPr>
             <a:r>
@@ -14280,7 +14015,7 @@
           <a:bodyPr wrap="square" lIns="0" tIns="114300" rIns="114300" bIns="0" rtlCol="0" anchor="ctr"/>
           <a:lstStyle/>
           <a:p>
-            <a:pPr algn="r" indent="0" marL="0">
+            <a:pPr marL="0" indent="0" algn="r">
               <a:buNone/>
             </a:pPr>
             <a:r>
@@ -14306,7 +14041,7 @@
         </p:nvSpPr>
         <p:spPr>
           <a:xfrm>
-            <a:off x="9550689" y="3886200"/>
+            <a:off x="9490307" y="3825818"/>
             <a:ext cx="1041293" cy="133350"/>
           </a:xfrm>
           <a:prstGeom prst="rect">
@@ -14319,7 +14054,7 @@
           <a:bodyPr wrap="square" lIns="0" tIns="114300" rIns="114300" bIns="0" rtlCol="0" anchor="ctr"/>
           <a:lstStyle/>
           <a:p>
-            <a:pPr algn="r" indent="0" marL="0">
+            <a:pPr marL="0" indent="0" algn="r">
               <a:buNone/>
             </a:pPr>
             <a:r>
@@ -14358,7 +14093,7 @@
           <a:bodyPr wrap="square" lIns="0" tIns="114300" rIns="114300" bIns="0" rtlCol="0" anchor="ctr"/>
           <a:lstStyle/>
           <a:p>
-            <a:pPr algn="r" indent="0" marL="0">
+            <a:pPr marL="0" indent="0" algn="r">
               <a:buNone/>
             </a:pPr>
             <a:r>
@@ -14384,7 +14119,7 @@
         </p:nvSpPr>
         <p:spPr>
           <a:xfrm>
-            <a:off x="9550689" y="4277023"/>
+            <a:off x="9490307" y="4216641"/>
             <a:ext cx="1041293" cy="133350"/>
           </a:xfrm>
           <a:prstGeom prst="rect">
@@ -14397,7 +14132,7 @@
           <a:bodyPr wrap="square" lIns="0" tIns="114300" rIns="114300" bIns="0" rtlCol="0" anchor="ctr"/>
           <a:lstStyle/>
           <a:p>
-            <a:pPr algn="r" indent="0" marL="0">
+            <a:pPr marL="0" indent="0" algn="r">
               <a:buNone/>
             </a:pPr>
             <a:r>
@@ -14436,7 +14171,7 @@
           <a:bodyPr wrap="square" lIns="0" tIns="114300" rIns="114300" bIns="0" rtlCol="0" anchor="ctr"/>
           <a:lstStyle/>
           <a:p>
-            <a:pPr algn="r" indent="0" marL="0">
+            <a:pPr marL="0" indent="0" algn="r">
               <a:buNone/>
             </a:pPr>
             <a:r>
@@ -14475,7 +14210,7 @@
           <a:bodyPr wrap="square" lIns="0" tIns="114300" rIns="114300" bIns="0" rtlCol="0" anchor="ctr"/>
           <a:lstStyle/>
           <a:p>
-            <a:pPr algn="r" indent="0" marL="0">
+            <a:pPr marL="0" indent="0" algn="r">
               <a:buNone/>
             </a:pPr>
             <a:r>
@@ -14501,7 +14236,7 @@
         </p:nvSpPr>
         <p:spPr>
           <a:xfrm>
-            <a:off x="9550689" y="4667845"/>
+            <a:off x="9490307" y="4607463"/>
             <a:ext cx="1041293" cy="133350"/>
           </a:xfrm>
           <a:prstGeom prst="rect">
@@ -14514,7 +14249,7 @@
           <a:bodyPr wrap="square" lIns="0" tIns="114300" rIns="114300" bIns="0" rtlCol="0" anchor="ctr"/>
           <a:lstStyle/>
           <a:p>
-            <a:pPr algn="r" indent="0" marL="0">
+            <a:pPr marL="0" indent="0" algn="r">
               <a:buNone/>
             </a:pPr>
             <a:r>
@@ -14553,7 +14288,7 @@
           <a:bodyPr wrap="square" lIns="0" tIns="114300" rIns="114300" bIns="0" rtlCol="0" anchor="ctr"/>
           <a:lstStyle/>
           <a:p>
-            <a:pPr algn="r" indent="0" marL="0">
+            <a:pPr marL="0" indent="0" algn="r">
               <a:buNone/>
             </a:pPr>
             <a:r>
@@ -14592,7 +14327,7 @@
           <a:bodyPr wrap="square" lIns="0" tIns="114300" rIns="114300" bIns="0" rtlCol="0" anchor="ctr"/>
           <a:lstStyle/>
           <a:p>
-            <a:pPr algn="r" indent="0" marL="0">
+            <a:pPr marL="0" indent="0" algn="r">
               <a:buNone/>
             </a:pPr>
             <a:r>
@@ -14618,7 +14353,7 @@
         </p:nvSpPr>
         <p:spPr>
           <a:xfrm>
-            <a:off x="9550689" y="5058668"/>
+            <a:off x="9490307" y="4998286"/>
             <a:ext cx="1041293" cy="133350"/>
           </a:xfrm>
           <a:prstGeom prst="rect">
@@ -14631,7 +14366,7 @@
           <a:bodyPr wrap="square" lIns="0" tIns="114300" rIns="114300" bIns="0" rtlCol="0" anchor="ctr"/>
           <a:lstStyle/>
           <a:p>
-            <a:pPr algn="r" indent="0" marL="0">
+            <a:pPr marL="0" indent="0" algn="r">
               <a:buNone/>
             </a:pPr>
             <a:r>
@@ -14950,4 +14685,319 @@
     </a:ext>
   </a:extLst>
 </a:theme>
+</file>
+
+<file path=ppt/theme/theme2.xml><?xml version="1.0" encoding="utf-8"?>
+<a:theme xmlns:a="http://schemas.openxmlformats.org/drawingml/2006/main" name="Office Theme">
+  <a:themeElements>
+    <a:clrScheme name="Office">
+      <a:dk1>
+        <a:sysClr val="windowText" lastClr="000000"/>
+      </a:dk1>
+      <a:lt1>
+        <a:sysClr val="window" lastClr="FFFFFF"/>
+      </a:lt1>
+      <a:dk2>
+        <a:srgbClr val="0E2841"/>
+      </a:dk2>
+      <a:lt2>
+        <a:srgbClr val="E8E8E8"/>
+      </a:lt2>
+      <a:accent1>
+        <a:srgbClr val="156082"/>
+      </a:accent1>
+      <a:accent2>
+        <a:srgbClr val="E97132"/>
+      </a:accent2>
+      <a:accent3>
+        <a:srgbClr val="196B24"/>
+      </a:accent3>
+      <a:accent4>
+        <a:srgbClr val="0F9ED5"/>
+      </a:accent4>
+      <a:accent5>
+        <a:srgbClr val="A02B93"/>
+      </a:accent5>
+      <a:accent6>
+        <a:srgbClr val="4EA72E"/>
+      </a:accent6>
+      <a:hlink>
+        <a:srgbClr val="467886"/>
+      </a:hlink>
+      <a:folHlink>
+        <a:srgbClr val="96607D"/>
+      </a:folHlink>
+    </a:clrScheme>
+    <a:fontScheme name="Office">
+      <a:majorFont>
+        <a:latin typeface="Aptos Display" panose="02110004020202020204"/>
+        <a:ea typeface=""/>
+        <a:cs typeface=""/>
+        <a:font script="Jpan" typeface="游ゴシック Light"/>
+        <a:font script="Hang" typeface="맑은 고딕"/>
+        <a:font script="Hans" typeface="等线 Light"/>
+        <a:font script="Hant" typeface="新細明體"/>
+        <a:font script="Arab" typeface="Times New Roman"/>
+        <a:font script="Hebr" typeface="Times New Roman"/>
+        <a:font script="Thai" typeface="Angsana New"/>
+        <a:font script="Ethi" typeface="Nyala"/>
+        <a:font script="Beng" typeface="Vrinda"/>
+        <a:font script="Gujr" typeface="Shruti"/>
+        <a:font script="Khmr" typeface="MoolBoran"/>
+        <a:font script="Knda" typeface="Tunga"/>
+        <a:font script="Guru" typeface="Raavi"/>
+        <a:font script="Cans" typeface="Euphemia"/>
+        <a:font script="Cher" typeface="Plantagenet Cherokee"/>
+        <a:font script="Yiii" typeface="Microsoft Yi Baiti"/>
+        <a:font script="Tibt" typeface="Microsoft Himalaya"/>
+        <a:font script="Thaa" typeface="MV Boli"/>
+        <a:font script="Deva" typeface="Mangal"/>
+        <a:font script="Telu" typeface="Gautami"/>
+        <a:font script="Taml" typeface="Latha"/>
+        <a:font script="Syrc" typeface="Estrangelo Edessa"/>
+        <a:font script="Orya" typeface="Kalinga"/>
+        <a:font script="Mlym" typeface="Kartika"/>
+        <a:font script="Laoo" typeface="DokChampa"/>
+        <a:font script="Sinh" typeface="Iskoola Pota"/>
+        <a:font script="Mong" typeface="Mongolian Baiti"/>
+        <a:font script="Viet" typeface="Times New Roman"/>
+        <a:font script="Uigh" typeface="Microsoft Uighur"/>
+        <a:font script="Geor" typeface="Sylfaen"/>
+        <a:font script="Armn" typeface="Arial"/>
+        <a:font script="Bugi" typeface="Leelawadee UI"/>
+        <a:font script="Bopo" typeface="Microsoft JhengHei"/>
+        <a:font script="Java" typeface="Javanese Text"/>
+        <a:font script="Lisu" typeface="Segoe UI"/>
+        <a:font script="Mymr" typeface="Myanmar Text"/>
+        <a:font script="Nkoo" typeface="Ebrima"/>
+        <a:font script="Olck" typeface="Nirmala UI"/>
+        <a:font script="Osma" typeface="Ebrima"/>
+        <a:font script="Phag" typeface="Phagspa"/>
+        <a:font script="Syrn" typeface="Estrangelo Edessa"/>
+        <a:font script="Syrj" typeface="Estrangelo Edessa"/>
+        <a:font script="Syre" typeface="Estrangelo Edessa"/>
+        <a:font script="Sora" typeface="Nirmala UI"/>
+        <a:font script="Tale" typeface="Microsoft Tai Le"/>
+        <a:font script="Talu" typeface="Microsoft New Tai Lue"/>
+        <a:font script="Tfng" typeface="Ebrima"/>
+      </a:majorFont>
+      <a:minorFont>
+        <a:latin typeface="Aptos" panose="02110004020202020204"/>
+        <a:ea typeface=""/>
+        <a:cs typeface=""/>
+        <a:font script="Jpan" typeface="游ゴシック"/>
+        <a:font script="Hang" typeface="맑은 고딕"/>
+        <a:font script="Hans" typeface="等线"/>
+        <a:font script="Hant" typeface="新細明體"/>
+        <a:font script="Arab" typeface="Arial"/>
+        <a:font script="Hebr" typeface="Arial"/>
+        <a:font script="Thai" typeface="Cordia New"/>
+        <a:font script="Ethi" typeface="Nyala"/>
+        <a:font script="Beng" typeface="Vrinda"/>
+        <a:font script="Gujr" typeface="Shruti"/>
+        <a:font script="Khmr" typeface="DaunPenh"/>
+        <a:font script="Knda" typeface="Tunga"/>
+        <a:font script="Guru" typeface="Raavi"/>
+        <a:font script="Cans" typeface="Euphemia"/>
+        <a:font script="Cher" typeface="Plantagenet Cherokee"/>
+        <a:font script="Yiii" typeface="Microsoft Yi Baiti"/>
+        <a:font script="Tibt" typeface="Microsoft Himalaya"/>
+        <a:font script="Thaa" typeface="MV Boli"/>
+        <a:font script="Deva" typeface="Mangal"/>
+        <a:font script="Telu" typeface="Gautami"/>
+        <a:font script="Taml" typeface="Latha"/>
+        <a:font script="Syrc" typeface="Estrangelo Edessa"/>
+        <a:font script="Orya" typeface="Kalinga"/>
+        <a:font script="Mlym" typeface="Kartika"/>
+        <a:font script="Laoo" typeface="DokChampa"/>
+        <a:font script="Sinh" typeface="Iskoola Pota"/>
+        <a:font script="Mong" typeface="Mongolian Baiti"/>
+        <a:font script="Viet" typeface="Arial"/>
+        <a:font script="Uigh" typeface="Microsoft Uighur"/>
+        <a:font script="Geor" typeface="Sylfaen"/>
+        <a:font script="Armn" typeface="Arial"/>
+        <a:font script="Bugi" typeface="Leelawadee UI"/>
+        <a:font script="Bopo" typeface="Microsoft JhengHei"/>
+        <a:font script="Java" typeface="Javanese Text"/>
+        <a:font script="Lisu" typeface="Segoe UI"/>
+        <a:font script="Mymr" typeface="Myanmar Text"/>
+        <a:font script="Nkoo" typeface="Ebrima"/>
+        <a:font script="Olck" typeface="Nirmala UI"/>
+        <a:font script="Osma" typeface="Ebrima"/>
+        <a:font script="Phag" typeface="Phagspa"/>
+        <a:font script="Syrn" typeface="Estrangelo Edessa"/>
+        <a:font script="Syrj" typeface="Estrangelo Edessa"/>
+        <a:font script="Syre" typeface="Estrangelo Edessa"/>
+        <a:font script="Sora" typeface="Nirmala UI"/>
+        <a:font script="Tale" typeface="Microsoft Tai Le"/>
+        <a:font script="Talu" typeface="Microsoft New Tai Lue"/>
+        <a:font script="Tfng" typeface="Ebrima"/>
+      </a:minorFont>
+    </a:fontScheme>
+    <a:fmtScheme name="Office">
+      <a:fillStyleLst>
+        <a:solidFill>
+          <a:schemeClr val="phClr"/>
+        </a:solidFill>
+        <a:gradFill rotWithShape="1">
+          <a:gsLst>
+            <a:gs pos="0">
+              <a:schemeClr val="phClr">
+                <a:lumMod val="110000"/>
+                <a:satMod val="105000"/>
+                <a:tint val="67000"/>
+              </a:schemeClr>
+            </a:gs>
+            <a:gs pos="50000">
+              <a:schemeClr val="phClr">
+                <a:lumMod val="105000"/>
+                <a:satMod val="103000"/>
+                <a:tint val="73000"/>
+              </a:schemeClr>
+            </a:gs>
+            <a:gs pos="100000">
+              <a:schemeClr val="phClr">
+                <a:lumMod val="105000"/>
+                <a:satMod val="109000"/>
+                <a:tint val="81000"/>
+              </a:schemeClr>
+            </a:gs>
+          </a:gsLst>
+          <a:lin ang="5400000" scaled="0"/>
+        </a:gradFill>
+        <a:gradFill rotWithShape="1">
+          <a:gsLst>
+            <a:gs pos="0">
+              <a:schemeClr val="phClr">
+                <a:satMod val="103000"/>
+                <a:lumMod val="102000"/>
+                <a:tint val="94000"/>
+              </a:schemeClr>
+            </a:gs>
+            <a:gs pos="50000">
+              <a:schemeClr val="phClr">
+                <a:satMod val="110000"/>
+                <a:lumMod val="100000"/>
+                <a:shade val="100000"/>
+              </a:schemeClr>
+            </a:gs>
+            <a:gs pos="100000">
+              <a:schemeClr val="phClr">
+                <a:lumMod val="99000"/>
+                <a:satMod val="120000"/>
+                <a:shade val="78000"/>
+              </a:schemeClr>
+            </a:gs>
+          </a:gsLst>
+          <a:lin ang="5400000" scaled="0"/>
+        </a:gradFill>
+      </a:fillStyleLst>
+      <a:lnStyleLst>
+        <a:ln w="12700" cap="flat" cmpd="sng" algn="ctr">
+          <a:solidFill>
+            <a:schemeClr val="phClr"/>
+          </a:solidFill>
+          <a:prstDash val="solid"/>
+          <a:miter lim="800000"/>
+        </a:ln>
+        <a:ln w="19050" cap="flat" cmpd="sng" algn="ctr">
+          <a:solidFill>
+            <a:schemeClr val="phClr"/>
+          </a:solidFill>
+          <a:prstDash val="solid"/>
+          <a:miter lim="800000"/>
+        </a:ln>
+        <a:ln w="25400" cap="flat" cmpd="sng" algn="ctr">
+          <a:solidFill>
+            <a:schemeClr val="phClr"/>
+          </a:solidFill>
+          <a:prstDash val="solid"/>
+          <a:miter lim="800000"/>
+        </a:ln>
+      </a:lnStyleLst>
+      <a:effectStyleLst>
+        <a:effectStyle>
+          <a:effectLst/>
+        </a:effectStyle>
+        <a:effectStyle>
+          <a:effectLst/>
+        </a:effectStyle>
+        <a:effectStyle>
+          <a:effectLst>
+            <a:outerShdw blurRad="57150" dist="19050" dir="5400000" algn="ctr" rotWithShape="0">
+              <a:srgbClr val="000000">
+                <a:alpha val="63000"/>
+              </a:srgbClr>
+            </a:outerShdw>
+          </a:effectLst>
+        </a:effectStyle>
+      </a:effectStyleLst>
+      <a:bgFillStyleLst>
+        <a:solidFill>
+          <a:schemeClr val="phClr"/>
+        </a:solidFill>
+        <a:solidFill>
+          <a:schemeClr val="phClr">
+            <a:tint val="95000"/>
+            <a:satMod val="170000"/>
+          </a:schemeClr>
+        </a:solidFill>
+        <a:gradFill rotWithShape="1">
+          <a:gsLst>
+            <a:gs pos="0">
+              <a:schemeClr val="phClr">
+                <a:tint val="93000"/>
+                <a:satMod val="150000"/>
+                <a:shade val="98000"/>
+                <a:lumMod val="102000"/>
+              </a:schemeClr>
+            </a:gs>
+            <a:gs pos="50000">
+              <a:schemeClr val="phClr">
+                <a:tint val="98000"/>
+                <a:satMod val="130000"/>
+                <a:shade val="90000"/>
+                <a:lumMod val="103000"/>
+              </a:schemeClr>
+            </a:gs>
+            <a:gs pos="100000">
+              <a:schemeClr val="phClr">
+                <a:shade val="63000"/>
+                <a:satMod val="120000"/>
+              </a:schemeClr>
+            </a:gs>
+          </a:gsLst>
+          <a:lin ang="5400000" scaled="0"/>
+        </a:gradFill>
+      </a:bgFillStyleLst>
+    </a:fmtScheme>
+  </a:themeElements>
+  <a:objectDefaults>
+    <a:lnDef>
+      <a:spPr/>
+      <a:bodyPr/>
+      <a:lstStyle/>
+      <a:style>
+        <a:lnRef idx="2">
+          <a:schemeClr val="accent1"/>
+        </a:lnRef>
+        <a:fillRef idx="0">
+          <a:schemeClr val="accent1"/>
+        </a:fillRef>
+        <a:effectRef idx="1">
+          <a:schemeClr val="accent1"/>
+        </a:effectRef>
+        <a:fontRef idx="minor">
+          <a:schemeClr val="tx1"/>
+        </a:fontRef>
+      </a:style>
+    </a:lnDef>
+  </a:objectDefaults>
+  <a:extraClrSchemeLst/>
+  <a:extLst>
+    <a:ext uri="{05A4C25C-085E-4340-85A3-A5531E510DB2}">
+      <thm15:themeFamily xmlns:thm15="http://schemas.microsoft.com/office/thememl/2012/main" name="Office Theme" id="{2E142A2C-CD16-42D6-873A-C26D2A0506FA}" vid="{1BDDFF52-6CD6-40A5-AB3C-68EB2F1E4D0A}"/>
+    </a:ext>
+  </a:extLst>
+</a:theme>
 </file>
</xml_diff>